<commit_message>
update image display in slide
</commit_message>
<xml_diff>
--- a/_static/images/concurrency/Presentation1.pptx
+++ b/_static/images/concurrency/Presentation1.pptx
@@ -25,6 +25,7 @@
     <p:sldId id="273" r:id="rId19"/>
     <p:sldId id="274" r:id="rId20"/>
     <p:sldId id="275" r:id="rId21"/>
+    <p:sldId id="276" r:id="rId22"/>
   </p:sldIdLst>
   <p:sldSz cx="12192000" cy="6858000"/>
   <p:notesSz cx="6858000" cy="9144000"/>
@@ -278,7 +279,7 @@
           <a:p>
             <a:fld id="{8864B806-D088-C24B-BAA0-8204A6CA2F81}" type="datetimeFigureOut">
               <a:rPr lang="en-US" smtClean="0"/>
-              <a:t>9/1/26</a:t>
+              <a:t>9/5/26</a:t>
             </a:fld>
             <a:endParaRPr lang="en-US"/>
           </a:p>
@@ -476,7 +477,7 @@
           <a:p>
             <a:fld id="{8864B806-D088-C24B-BAA0-8204A6CA2F81}" type="datetimeFigureOut">
               <a:rPr lang="en-US" smtClean="0"/>
-              <a:t>9/1/26</a:t>
+              <a:t>9/5/26</a:t>
             </a:fld>
             <a:endParaRPr lang="en-US"/>
           </a:p>
@@ -684,7 +685,7 @@
           <a:p>
             <a:fld id="{8864B806-D088-C24B-BAA0-8204A6CA2F81}" type="datetimeFigureOut">
               <a:rPr lang="en-US" smtClean="0"/>
-              <a:t>9/1/26</a:t>
+              <a:t>9/5/26</a:t>
             </a:fld>
             <a:endParaRPr lang="en-US"/>
           </a:p>
@@ -882,7 +883,7 @@
           <a:p>
             <a:fld id="{8864B806-D088-C24B-BAA0-8204A6CA2F81}" type="datetimeFigureOut">
               <a:rPr lang="en-US" smtClean="0"/>
-              <a:t>9/1/26</a:t>
+              <a:t>9/5/26</a:t>
             </a:fld>
             <a:endParaRPr lang="en-US"/>
           </a:p>
@@ -1157,7 +1158,7 @@
           <a:p>
             <a:fld id="{8864B806-D088-C24B-BAA0-8204A6CA2F81}" type="datetimeFigureOut">
               <a:rPr lang="en-US" smtClean="0"/>
-              <a:t>9/1/26</a:t>
+              <a:t>9/5/26</a:t>
             </a:fld>
             <a:endParaRPr lang="en-US"/>
           </a:p>
@@ -1422,7 +1423,7 @@
           <a:p>
             <a:fld id="{8864B806-D088-C24B-BAA0-8204A6CA2F81}" type="datetimeFigureOut">
               <a:rPr lang="en-US" smtClean="0"/>
-              <a:t>9/1/26</a:t>
+              <a:t>9/5/26</a:t>
             </a:fld>
             <a:endParaRPr lang="en-US"/>
           </a:p>
@@ -1834,7 +1835,7 @@
           <a:p>
             <a:fld id="{8864B806-D088-C24B-BAA0-8204A6CA2F81}" type="datetimeFigureOut">
               <a:rPr lang="en-US" smtClean="0"/>
-              <a:t>9/1/26</a:t>
+              <a:t>9/5/26</a:t>
             </a:fld>
             <a:endParaRPr lang="en-US"/>
           </a:p>
@@ -1975,7 +1976,7 @@
           <a:p>
             <a:fld id="{8864B806-D088-C24B-BAA0-8204A6CA2F81}" type="datetimeFigureOut">
               <a:rPr lang="en-US" smtClean="0"/>
-              <a:t>9/1/26</a:t>
+              <a:t>9/5/26</a:t>
             </a:fld>
             <a:endParaRPr lang="en-US"/>
           </a:p>
@@ -2088,7 +2089,7 @@
           <a:p>
             <a:fld id="{8864B806-D088-C24B-BAA0-8204A6CA2F81}" type="datetimeFigureOut">
               <a:rPr lang="en-US" smtClean="0"/>
-              <a:t>9/1/26</a:t>
+              <a:t>9/5/26</a:t>
             </a:fld>
             <a:endParaRPr lang="en-US"/>
           </a:p>
@@ -2399,7 +2400,7 @@
           <a:p>
             <a:fld id="{8864B806-D088-C24B-BAA0-8204A6CA2F81}" type="datetimeFigureOut">
               <a:rPr lang="en-US" smtClean="0"/>
-              <a:t>9/1/26</a:t>
+              <a:t>9/5/26</a:t>
             </a:fld>
             <a:endParaRPr lang="en-US"/>
           </a:p>
@@ -2687,7 +2688,7 @@
           <a:p>
             <a:fld id="{8864B806-D088-C24B-BAA0-8204A6CA2F81}" type="datetimeFigureOut">
               <a:rPr lang="en-US" smtClean="0"/>
-              <a:t>9/1/26</a:t>
+              <a:t>9/5/26</a:t>
             </a:fld>
             <a:endParaRPr lang="en-US"/>
           </a:p>
@@ -2928,7 +2929,7 @@
           <a:p>
             <a:fld id="{8864B806-D088-C24B-BAA0-8204A6CA2F81}" type="datetimeFigureOut">
               <a:rPr lang="en-US" smtClean="0"/>
-              <a:t>9/1/26</a:t>
+              <a:t>9/5/26</a:t>
             </a:fld>
             <a:endParaRPr lang="en-US"/>
           </a:p>
@@ -12461,7 +12462,7 @@
           <p:nvPr>
             <p:extLst>
               <p:ext uri="{D42A27DB-BD31-4B8C-83A1-F6EECF244321}">
-                <p14:modId xmlns:p14="http://schemas.microsoft.com/office/powerpoint/2010/main" val="821367378"/>
+                <p14:modId xmlns:p14="http://schemas.microsoft.com/office/powerpoint/2010/main" val="2417778361"/>
               </p:ext>
             </p:extLst>
           </p:nvPr>
@@ -14312,7 +14313,7 @@
           <p:nvPr>
             <p:extLst>
               <p:ext uri="{D42A27DB-BD31-4B8C-83A1-F6EECF244321}">
-                <p14:modId xmlns:p14="http://schemas.microsoft.com/office/powerpoint/2010/main" val="860989950"/>
+                <p14:modId xmlns:p14="http://schemas.microsoft.com/office/powerpoint/2010/main" val="3879758332"/>
               </p:ext>
             </p:extLst>
           </p:nvPr>
@@ -15013,6 +15014,3640 @@
 </p:sld>
 </file>
 
+<file path=ppt/slides/slide21.xml><?xml version="1.0" encoding="utf-8"?>
+<p:sld xmlns:a="http://schemas.openxmlformats.org/drawingml/2006/main" xmlns:r="http://schemas.openxmlformats.org/officeDocument/2006/relationships" xmlns:p="http://schemas.openxmlformats.org/presentationml/2006/main">
+  <p:cSld>
+    <p:spTree>
+      <p:nvGrpSpPr>
+        <p:cNvPr id="1" name=""/>
+        <p:cNvGrpSpPr/>
+        <p:nvPr/>
+      </p:nvGrpSpPr>
+      <p:grpSpPr>
+        <a:xfrm>
+          <a:off x="0" y="0"/>
+          <a:ext cx="0" cy="0"/>
+          <a:chOff x="0" y="0"/>
+          <a:chExt cx="0" cy="0"/>
+        </a:xfrm>
+      </p:grpSpPr>
+      <p:sp>
+        <p:nvSpPr>
+          <p:cNvPr id="4" name="Shape 1">
+            <a:extLst>
+              <a:ext uri="{FF2B5EF4-FFF2-40B4-BE49-F238E27FC236}">
+                <a16:creationId xmlns:a16="http://schemas.microsoft.com/office/drawing/2014/main" id="{78DCE094-14BE-179A-9B3B-D7C8652F192A}"/>
+              </a:ext>
+            </a:extLst>
+          </p:cNvPr>
+          <p:cNvSpPr/>
+          <p:nvPr/>
+        </p:nvSpPr>
+        <p:spPr>
+          <a:xfrm>
+            <a:off x="182880" y="640080"/>
+            <a:ext cx="2926080" cy="2423160"/>
+          </a:xfrm>
+          <a:prstGeom prst="roundRect">
+            <a:avLst>
+              <a:gd name="adj" fmla="val 3019"/>
+            </a:avLst>
+          </a:prstGeom>
+          <a:solidFill>
+            <a:srgbClr val="EAF6FF"/>
+          </a:solidFill>
+          <a:ln w="17780">
+            <a:solidFill>
+              <a:srgbClr val="0E76D8"/>
+            </a:solidFill>
+            <a:prstDash val="solid"/>
+          </a:ln>
+          <a:effectLst>
+            <a:outerShdw blurRad="19050" dist="7620" dir="2700000" algn="bl" rotWithShape="0">
+              <a:srgbClr val="000000">
+                <a:alpha val="10000"/>
+              </a:srgbClr>
+            </a:outerShdw>
+          </a:effectLst>
+        </p:spPr>
+        <p:txBody>
+          <a:bodyPr/>
+          <a:lstStyle/>
+          <a:p>
+            <a:endParaRPr lang="en-US"/>
+          </a:p>
+        </p:txBody>
+      </p:sp>
+      <p:sp>
+        <p:nvSpPr>
+          <p:cNvPr id="5" name="Text 2">
+            <a:extLst>
+              <a:ext uri="{FF2B5EF4-FFF2-40B4-BE49-F238E27FC236}">
+                <a16:creationId xmlns:a16="http://schemas.microsoft.com/office/drawing/2014/main" id="{DBACFE59-665C-8601-F6F6-0C36AC4F4F0B}"/>
+              </a:ext>
+            </a:extLst>
+          </p:cNvPr>
+          <p:cNvSpPr/>
+          <p:nvPr/>
+        </p:nvSpPr>
+        <p:spPr>
+          <a:xfrm>
+            <a:off x="292608" y="749808"/>
+            <a:ext cx="256032" cy="228600"/>
+          </a:xfrm>
+          <a:prstGeom prst="rect">
+            <a:avLst/>
+          </a:prstGeom>
+          <a:noFill/>
+          <a:ln/>
+        </p:spPr>
+        <p:txBody>
+          <a:bodyPr wrap="square" lIns="0" tIns="0" rIns="0" bIns="0" rtlCol="0" anchor="ctr"/>
+          <a:lstStyle/>
+          <a:p>
+            <a:pPr marL="0" indent="0" algn="ctr">
+              <a:buNone/>
+            </a:pPr>
+            <a:endParaRPr lang="en-US" sz="1800" dirty="0"/>
+          </a:p>
+        </p:txBody>
+      </p:sp>
+      <p:sp>
+        <p:nvSpPr>
+          <p:cNvPr id="6" name="Text 3">
+            <a:extLst>
+              <a:ext uri="{FF2B5EF4-FFF2-40B4-BE49-F238E27FC236}">
+                <a16:creationId xmlns:a16="http://schemas.microsoft.com/office/drawing/2014/main" id="{840C4E4D-7315-E9D6-05F8-D80FFDDF69EB}"/>
+              </a:ext>
+            </a:extLst>
+          </p:cNvPr>
+          <p:cNvSpPr/>
+          <p:nvPr/>
+        </p:nvSpPr>
+        <p:spPr>
+          <a:xfrm>
+            <a:off x="640080" y="722376"/>
+            <a:ext cx="2359152" cy="228600"/>
+          </a:xfrm>
+          <a:prstGeom prst="rect">
+            <a:avLst/>
+          </a:prstGeom>
+          <a:noFill/>
+          <a:ln/>
+        </p:spPr>
+        <p:txBody>
+          <a:bodyPr wrap="square" lIns="127" tIns="127" rIns="127" bIns="127" rtlCol="0" anchor="ctr">
+            <a:normAutofit lnSpcReduction="10000"/>
+          </a:bodyPr>
+          <a:lstStyle/>
+          <a:p>
+            <a:pPr marL="0" indent="0">
+              <a:buNone/>
+            </a:pPr>
+            <a:r>
+              <a:rPr lang="en-US" sz="1600" b="1" dirty="0">
+                <a:solidFill>
+                  <a:srgbClr val="0E76D8"/>
+                </a:solidFill>
+              </a:rPr>
+              <a:t>MainApp.java</a:t>
+            </a:r>
+            <a:endParaRPr lang="en-US" sz="1600" dirty="0"/>
+          </a:p>
+        </p:txBody>
+      </p:sp>
+      <p:sp>
+        <p:nvSpPr>
+          <p:cNvPr id="7" name="Text 4">
+            <a:extLst>
+              <a:ext uri="{FF2B5EF4-FFF2-40B4-BE49-F238E27FC236}">
+                <a16:creationId xmlns:a16="http://schemas.microsoft.com/office/drawing/2014/main" id="{D7280A48-5764-7515-CAF5-2C17C10C808F}"/>
+              </a:ext>
+            </a:extLst>
+          </p:cNvPr>
+          <p:cNvSpPr/>
+          <p:nvPr/>
+        </p:nvSpPr>
+        <p:spPr>
+          <a:xfrm>
+            <a:off x="640080" y="987552"/>
+            <a:ext cx="2359152" cy="164592"/>
+          </a:xfrm>
+          <a:prstGeom prst="rect">
+            <a:avLst/>
+          </a:prstGeom>
+          <a:noFill/>
+          <a:ln/>
+        </p:spPr>
+        <p:txBody>
+          <a:bodyPr wrap="square" lIns="127" tIns="127" rIns="127" bIns="127" rtlCol="0" anchor="ctr">
+            <a:normAutofit/>
+          </a:bodyPr>
+          <a:lstStyle/>
+          <a:p>
+            <a:pPr marL="0" indent="0">
+              <a:buNone/>
+            </a:pPr>
+            <a:r>
+              <a:rPr lang="en-US" sz="880" dirty="0">
+                <a:solidFill>
+                  <a:srgbClr val="0E76D8"/>
+                </a:solidFill>
+              </a:rPr>
+              <a:t>(Application entry point)</a:t>
+            </a:r>
+            <a:endParaRPr lang="en-US" sz="880" dirty="0"/>
+          </a:p>
+        </p:txBody>
+      </p:sp>
+      <p:sp>
+        <p:nvSpPr>
+          <p:cNvPr id="8" name="Shape 5">
+            <a:extLst>
+              <a:ext uri="{FF2B5EF4-FFF2-40B4-BE49-F238E27FC236}">
+                <a16:creationId xmlns:a16="http://schemas.microsoft.com/office/drawing/2014/main" id="{37F2EEE8-738B-FDF8-D8D0-00B463432512}"/>
+              </a:ext>
+            </a:extLst>
+          </p:cNvPr>
+          <p:cNvSpPr/>
+          <p:nvPr/>
+        </p:nvSpPr>
+        <p:spPr>
+          <a:xfrm>
+            <a:off x="274320" y="1170432"/>
+            <a:ext cx="2743200" cy="1600200"/>
+          </a:xfrm>
+          <a:prstGeom prst="roundRect">
+            <a:avLst>
+              <a:gd name="adj" fmla="val 2857"/>
+            </a:avLst>
+          </a:prstGeom>
+          <a:solidFill>
+            <a:srgbClr val="FFFFFF">
+              <a:alpha val="96000"/>
+            </a:srgbClr>
+          </a:solidFill>
+          <a:ln w="8890">
+            <a:solidFill>
+              <a:srgbClr val="D9E2EA"/>
+            </a:solidFill>
+            <a:prstDash val="solid"/>
+          </a:ln>
+        </p:spPr>
+        <p:txBody>
+          <a:bodyPr/>
+          <a:lstStyle/>
+          <a:p>
+            <a:endParaRPr lang="en-US"/>
+          </a:p>
+        </p:txBody>
+      </p:sp>
+      <p:sp>
+        <p:nvSpPr>
+          <p:cNvPr id="9" name="Text 6">
+            <a:extLst>
+              <a:ext uri="{FF2B5EF4-FFF2-40B4-BE49-F238E27FC236}">
+                <a16:creationId xmlns:a16="http://schemas.microsoft.com/office/drawing/2014/main" id="{0E2942B0-FA06-D630-DD3F-86FBF94A2B17}"/>
+              </a:ext>
+            </a:extLst>
+          </p:cNvPr>
+          <p:cNvSpPr/>
+          <p:nvPr/>
+        </p:nvSpPr>
+        <p:spPr>
+          <a:xfrm>
+            <a:off x="338328" y="1243584"/>
+            <a:ext cx="2615184" cy="1490472"/>
+          </a:xfrm>
+          <a:prstGeom prst="rect">
+            <a:avLst/>
+          </a:prstGeom>
+          <a:noFill/>
+          <a:ln/>
+        </p:spPr>
+        <p:txBody>
+          <a:bodyPr wrap="square" lIns="0" tIns="0" rIns="0" bIns="0" rtlCol="0" anchor="t">
+            <a:normAutofit/>
+          </a:bodyPr>
+          <a:lstStyle/>
+          <a:p>
+            <a:pPr marL="0" indent="0">
+              <a:buNone/>
+            </a:pPr>
+            <a:r>
+              <a:rPr lang="en-US" sz="800" dirty="0">
+                <a:solidFill>
+                  <a:srgbClr val="111111"/>
+                </a:solidFill>
+                <a:latin typeface="Courier New" pitchFamily="34" charset="0"/>
+                <a:ea typeface="Courier New" pitchFamily="34" charset="-122"/>
+                <a:cs typeface="Courier New" pitchFamily="34" charset="-120"/>
+              </a:rPr>
+              <a:t>@Override</a:t>
+            </a:r>
+            <a:endParaRPr lang="en-US" sz="800" dirty="0"/>
+          </a:p>
+          <a:p>
+            <a:pPr marL="0" indent="0">
+              <a:buNone/>
+            </a:pPr>
+            <a:r>
+              <a:rPr lang="en-US" sz="800" dirty="0">
+                <a:solidFill>
+                  <a:srgbClr val="111111"/>
+                </a:solidFill>
+                <a:latin typeface="Courier New" pitchFamily="34" charset="0"/>
+                <a:ea typeface="Courier New" pitchFamily="34" charset="-122"/>
+                <a:cs typeface="Courier New" pitchFamily="34" charset="-120"/>
+              </a:rPr>
+              <a:t>public void start(Stage stage)</a:t>
+            </a:r>
+            <a:endParaRPr lang="en-US" sz="800" dirty="0"/>
+          </a:p>
+          <a:p>
+            <a:pPr marL="0" indent="0">
+              <a:buNone/>
+            </a:pPr>
+            <a:r>
+              <a:rPr lang="en-US" sz="800" dirty="0">
+                <a:solidFill>
+                  <a:srgbClr val="111111"/>
+                </a:solidFill>
+                <a:latin typeface="Courier New" pitchFamily="34" charset="0"/>
+                <a:ea typeface="Courier New" pitchFamily="34" charset="-122"/>
+                <a:cs typeface="Courier New" pitchFamily="34" charset="-120"/>
+              </a:rPr>
+              <a:t>    throws Exception {</a:t>
+            </a:r>
+            <a:endParaRPr lang="en-US" sz="800" dirty="0"/>
+          </a:p>
+          <a:p>
+            <a:pPr marL="0" indent="0">
+              <a:buNone/>
+            </a:pPr>
+            <a:r>
+              <a:rPr lang="en-US" sz="800" dirty="0">
+                <a:solidFill>
+                  <a:srgbClr val="111111"/>
+                </a:solidFill>
+                <a:latin typeface="Courier New" pitchFamily="34" charset="0"/>
+                <a:ea typeface="Courier New" pitchFamily="34" charset="-122"/>
+                <a:cs typeface="Courier New" pitchFamily="34" charset="-120"/>
+              </a:rPr>
+              <a:t>  Parent root = FXMLLoader.load(</a:t>
+            </a:r>
+            <a:endParaRPr lang="en-US" sz="800" dirty="0"/>
+          </a:p>
+          <a:p>
+            <a:pPr marL="0" indent="0">
+              <a:buNone/>
+            </a:pPr>
+            <a:r>
+              <a:rPr lang="en-US" sz="800" dirty="0">
+                <a:solidFill>
+                  <a:srgbClr val="111111"/>
+                </a:solidFill>
+                <a:latin typeface="Courier New" pitchFamily="34" charset="0"/>
+                <a:ea typeface="Courier New" pitchFamily="34" charset="-122"/>
+                <a:cs typeface="Courier New" pitchFamily="34" charset="-120"/>
+              </a:rPr>
+              <a:t>    getClass().getResource("login.fxml"));</a:t>
+            </a:r>
+            <a:endParaRPr lang="en-US" sz="800" dirty="0"/>
+          </a:p>
+          <a:p>
+            <a:pPr marL="0" indent="0">
+              <a:buNone/>
+            </a:pPr>
+            <a:endParaRPr lang="en-US" sz="800" dirty="0"/>
+          </a:p>
+          <a:p>
+            <a:pPr marL="0" indent="0">
+              <a:buNone/>
+            </a:pPr>
+            <a:r>
+              <a:rPr lang="en-US" sz="800" dirty="0">
+                <a:solidFill>
+                  <a:srgbClr val="111111"/>
+                </a:solidFill>
+                <a:latin typeface="Courier New" pitchFamily="34" charset="0"/>
+                <a:ea typeface="Courier New" pitchFamily="34" charset="-122"/>
+                <a:cs typeface="Courier New" pitchFamily="34" charset="-120"/>
+              </a:rPr>
+              <a:t>  Scene scene = new Scene(root);</a:t>
+            </a:r>
+            <a:endParaRPr lang="en-US" sz="800" dirty="0"/>
+          </a:p>
+          <a:p>
+            <a:pPr marL="0" indent="0">
+              <a:buNone/>
+            </a:pPr>
+            <a:r>
+              <a:rPr lang="en-US" sz="800" dirty="0">
+                <a:solidFill>
+                  <a:srgbClr val="111111"/>
+                </a:solidFill>
+                <a:latin typeface="Courier New" pitchFamily="34" charset="0"/>
+                <a:ea typeface="Courier New" pitchFamily="34" charset="-122"/>
+                <a:cs typeface="Courier New" pitchFamily="34" charset="-120"/>
+              </a:rPr>
+              <a:t>  stage.setScene(scene);</a:t>
+            </a:r>
+            <a:endParaRPr lang="en-US" sz="800" dirty="0"/>
+          </a:p>
+          <a:p>
+            <a:pPr marL="0" indent="0">
+              <a:buNone/>
+            </a:pPr>
+            <a:r>
+              <a:rPr lang="en-US" sz="800" dirty="0">
+                <a:solidFill>
+                  <a:srgbClr val="111111"/>
+                </a:solidFill>
+                <a:latin typeface="Courier New" pitchFamily="34" charset="0"/>
+                <a:ea typeface="Courier New" pitchFamily="34" charset="-122"/>
+                <a:cs typeface="Courier New" pitchFamily="34" charset="-120"/>
+              </a:rPr>
+              <a:t>  stage.setTitle("My App");</a:t>
+            </a:r>
+            <a:endParaRPr lang="en-US" sz="800" dirty="0"/>
+          </a:p>
+          <a:p>
+            <a:pPr marL="0" indent="0">
+              <a:buNone/>
+            </a:pPr>
+            <a:r>
+              <a:rPr lang="en-US" sz="800" dirty="0">
+                <a:solidFill>
+                  <a:srgbClr val="111111"/>
+                </a:solidFill>
+                <a:latin typeface="Courier New" pitchFamily="34" charset="0"/>
+                <a:ea typeface="Courier New" pitchFamily="34" charset="-122"/>
+                <a:cs typeface="Courier New" pitchFamily="34" charset="-120"/>
+              </a:rPr>
+              <a:t>  stage.show();</a:t>
+            </a:r>
+            <a:endParaRPr lang="en-US" sz="800" dirty="0"/>
+          </a:p>
+          <a:p>
+            <a:pPr marL="0" indent="0">
+              <a:buNone/>
+            </a:pPr>
+            <a:r>
+              <a:rPr lang="en-US" sz="800" dirty="0">
+                <a:solidFill>
+                  <a:srgbClr val="111111"/>
+                </a:solidFill>
+                <a:latin typeface="Courier New" pitchFamily="34" charset="0"/>
+                <a:ea typeface="Courier New" pitchFamily="34" charset="-122"/>
+                <a:cs typeface="Courier New" pitchFamily="34" charset="-120"/>
+              </a:rPr>
+              <a:t>}</a:t>
+            </a:r>
+            <a:endParaRPr lang="en-US" sz="800" dirty="0"/>
+          </a:p>
+        </p:txBody>
+      </p:sp>
+      <p:sp>
+        <p:nvSpPr>
+          <p:cNvPr id="10" name="Text 7">
+            <a:extLst>
+              <a:ext uri="{FF2B5EF4-FFF2-40B4-BE49-F238E27FC236}">
+                <a16:creationId xmlns:a16="http://schemas.microsoft.com/office/drawing/2014/main" id="{32A6386F-3E7D-A9B3-6CC3-A69591248FA7}"/>
+              </a:ext>
+            </a:extLst>
+          </p:cNvPr>
+          <p:cNvSpPr/>
+          <p:nvPr/>
+        </p:nvSpPr>
+        <p:spPr>
+          <a:xfrm>
+            <a:off x="292608" y="2770632"/>
+            <a:ext cx="2706624" cy="219456"/>
+          </a:xfrm>
+          <a:prstGeom prst="rect">
+            <a:avLst/>
+          </a:prstGeom>
+          <a:noFill/>
+          <a:ln/>
+        </p:spPr>
+        <p:txBody>
+          <a:bodyPr wrap="square" lIns="127" tIns="127" rIns="127" bIns="127" rtlCol="0" anchor="ctr">
+            <a:normAutofit/>
+          </a:bodyPr>
+          <a:lstStyle/>
+          <a:p>
+            <a:pPr marL="0" indent="0" algn="ctr">
+              <a:buNone/>
+            </a:pPr>
+            <a:r>
+              <a:rPr lang="en-US" sz="920" dirty="0">
+                <a:solidFill>
+                  <a:srgbClr val="0E76D8"/>
+                </a:solidFill>
+              </a:rPr>
+              <a:t>Loads the FXML and shows the window</a:t>
+            </a:r>
+            <a:endParaRPr lang="en-US" sz="920" dirty="0"/>
+          </a:p>
+        </p:txBody>
+      </p:sp>
+      <p:sp>
+        <p:nvSpPr>
+          <p:cNvPr id="11" name="Shape 8">
+            <a:extLst>
+              <a:ext uri="{FF2B5EF4-FFF2-40B4-BE49-F238E27FC236}">
+                <a16:creationId xmlns:a16="http://schemas.microsoft.com/office/drawing/2014/main" id="{174970EA-E6EE-310B-57F5-6DCE732A375A}"/>
+              </a:ext>
+            </a:extLst>
+          </p:cNvPr>
+          <p:cNvSpPr/>
+          <p:nvPr/>
+        </p:nvSpPr>
+        <p:spPr>
+          <a:xfrm>
+            <a:off x="6629400" y="640080"/>
+            <a:ext cx="2331720" cy="3063240"/>
+          </a:xfrm>
+          <a:prstGeom prst="roundRect">
+            <a:avLst>
+              <a:gd name="adj" fmla="val 3137"/>
+            </a:avLst>
+          </a:prstGeom>
+          <a:solidFill>
+            <a:srgbClr val="EAF8EE"/>
+          </a:solidFill>
+          <a:ln w="17780">
+            <a:solidFill>
+              <a:srgbClr val="12984B"/>
+            </a:solidFill>
+            <a:prstDash val="solid"/>
+          </a:ln>
+          <a:effectLst>
+            <a:outerShdw blurRad="19050" dist="7620" dir="2700000" algn="bl" rotWithShape="0">
+              <a:srgbClr val="000000">
+                <a:alpha val="10000"/>
+              </a:srgbClr>
+            </a:outerShdw>
+          </a:effectLst>
+        </p:spPr>
+        <p:txBody>
+          <a:bodyPr/>
+          <a:lstStyle/>
+          <a:p>
+            <a:endParaRPr lang="en-US"/>
+          </a:p>
+        </p:txBody>
+      </p:sp>
+      <p:sp>
+        <p:nvSpPr>
+          <p:cNvPr id="12" name="Text 9">
+            <a:extLst>
+              <a:ext uri="{FF2B5EF4-FFF2-40B4-BE49-F238E27FC236}">
+                <a16:creationId xmlns:a16="http://schemas.microsoft.com/office/drawing/2014/main" id="{B7DE323A-6FBE-55F4-B552-33F56AAE9ED3}"/>
+              </a:ext>
+            </a:extLst>
+          </p:cNvPr>
+          <p:cNvSpPr/>
+          <p:nvPr/>
+        </p:nvSpPr>
+        <p:spPr>
+          <a:xfrm>
+            <a:off x="6739128" y="749808"/>
+            <a:ext cx="256032" cy="228600"/>
+          </a:xfrm>
+          <a:prstGeom prst="rect">
+            <a:avLst/>
+          </a:prstGeom>
+          <a:noFill/>
+          <a:ln/>
+        </p:spPr>
+        <p:txBody>
+          <a:bodyPr wrap="square" lIns="0" tIns="0" rIns="0" bIns="0" rtlCol="0" anchor="ctr"/>
+          <a:lstStyle/>
+          <a:p>
+            <a:pPr marL="0" indent="0" algn="ctr">
+              <a:buNone/>
+            </a:pPr>
+            <a:endParaRPr lang="en-US" sz="1800" dirty="0"/>
+          </a:p>
+        </p:txBody>
+      </p:sp>
+      <p:sp>
+        <p:nvSpPr>
+          <p:cNvPr id="13" name="Text 10">
+            <a:extLst>
+              <a:ext uri="{FF2B5EF4-FFF2-40B4-BE49-F238E27FC236}">
+                <a16:creationId xmlns:a16="http://schemas.microsoft.com/office/drawing/2014/main" id="{403BE45D-9F2D-F71C-AE55-A366543EF0FC}"/>
+              </a:ext>
+            </a:extLst>
+          </p:cNvPr>
+          <p:cNvSpPr/>
+          <p:nvPr/>
+        </p:nvSpPr>
+        <p:spPr>
+          <a:xfrm>
+            <a:off x="7086600" y="722376"/>
+            <a:ext cx="1764792" cy="228600"/>
+          </a:xfrm>
+          <a:prstGeom prst="rect">
+            <a:avLst/>
+          </a:prstGeom>
+          <a:noFill/>
+          <a:ln/>
+        </p:spPr>
+        <p:txBody>
+          <a:bodyPr wrap="square" lIns="127" tIns="127" rIns="127" bIns="127" rtlCol="0" anchor="ctr">
+            <a:normAutofit lnSpcReduction="10000"/>
+          </a:bodyPr>
+          <a:lstStyle/>
+          <a:p>
+            <a:pPr marL="0" indent="0">
+              <a:buNone/>
+            </a:pPr>
+            <a:r>
+              <a:rPr lang="en-US" sz="1600" b="1" dirty="0">
+                <a:solidFill>
+                  <a:srgbClr val="12984B"/>
+                </a:solidFill>
+              </a:rPr>
+              <a:t>login.fxml</a:t>
+            </a:r>
+            <a:endParaRPr lang="en-US" sz="1600" dirty="0"/>
+          </a:p>
+        </p:txBody>
+      </p:sp>
+      <p:sp>
+        <p:nvSpPr>
+          <p:cNvPr id="14" name="Text 11">
+            <a:extLst>
+              <a:ext uri="{FF2B5EF4-FFF2-40B4-BE49-F238E27FC236}">
+                <a16:creationId xmlns:a16="http://schemas.microsoft.com/office/drawing/2014/main" id="{6E88F52A-47A9-A1ED-5492-EB345E607132}"/>
+              </a:ext>
+            </a:extLst>
+          </p:cNvPr>
+          <p:cNvSpPr/>
+          <p:nvPr/>
+        </p:nvSpPr>
+        <p:spPr>
+          <a:xfrm>
+            <a:off x="7086600" y="987552"/>
+            <a:ext cx="1764792" cy="164592"/>
+          </a:xfrm>
+          <a:prstGeom prst="rect">
+            <a:avLst/>
+          </a:prstGeom>
+          <a:noFill/>
+          <a:ln/>
+        </p:spPr>
+        <p:txBody>
+          <a:bodyPr wrap="square" lIns="127" tIns="127" rIns="127" bIns="127" rtlCol="0" anchor="ctr">
+            <a:normAutofit/>
+          </a:bodyPr>
+          <a:lstStyle/>
+          <a:p>
+            <a:pPr marL="0" indent="0">
+              <a:buNone/>
+            </a:pPr>
+            <a:r>
+              <a:rPr lang="en-US" sz="880" dirty="0">
+                <a:solidFill>
+                  <a:srgbClr val="12984B"/>
+                </a:solidFill>
+              </a:rPr>
+              <a:t>(UI layout definition)</a:t>
+            </a:r>
+            <a:endParaRPr lang="en-US" sz="880" dirty="0"/>
+          </a:p>
+        </p:txBody>
+      </p:sp>
+      <p:sp>
+        <p:nvSpPr>
+          <p:cNvPr id="15" name="Shape 12">
+            <a:extLst>
+              <a:ext uri="{FF2B5EF4-FFF2-40B4-BE49-F238E27FC236}">
+                <a16:creationId xmlns:a16="http://schemas.microsoft.com/office/drawing/2014/main" id="{6B286EBA-7F3C-6F6C-C235-65D6F812D8E4}"/>
+              </a:ext>
+            </a:extLst>
+          </p:cNvPr>
+          <p:cNvSpPr/>
+          <p:nvPr/>
+        </p:nvSpPr>
+        <p:spPr>
+          <a:xfrm>
+            <a:off x="6720840" y="1170432"/>
+            <a:ext cx="2148840" cy="2048256"/>
+          </a:xfrm>
+          <a:prstGeom prst="roundRect">
+            <a:avLst>
+              <a:gd name="adj" fmla="val 2128"/>
+            </a:avLst>
+          </a:prstGeom>
+          <a:solidFill>
+            <a:srgbClr val="FFFFFF">
+              <a:alpha val="96000"/>
+            </a:srgbClr>
+          </a:solidFill>
+          <a:ln w="8890">
+            <a:solidFill>
+              <a:srgbClr val="D9E2EA"/>
+            </a:solidFill>
+            <a:prstDash val="solid"/>
+          </a:ln>
+        </p:spPr>
+        <p:txBody>
+          <a:bodyPr/>
+          <a:lstStyle/>
+          <a:p>
+            <a:endParaRPr lang="en-US"/>
+          </a:p>
+        </p:txBody>
+      </p:sp>
+      <p:sp>
+        <p:nvSpPr>
+          <p:cNvPr id="16" name="Text 13">
+            <a:extLst>
+              <a:ext uri="{FF2B5EF4-FFF2-40B4-BE49-F238E27FC236}">
+                <a16:creationId xmlns:a16="http://schemas.microsoft.com/office/drawing/2014/main" id="{776D7073-9103-33E5-A3D8-A348D087F236}"/>
+              </a:ext>
+            </a:extLst>
+          </p:cNvPr>
+          <p:cNvSpPr/>
+          <p:nvPr/>
+        </p:nvSpPr>
+        <p:spPr>
+          <a:xfrm>
+            <a:off x="6784847" y="1243584"/>
+            <a:ext cx="2097081" cy="1944792"/>
+          </a:xfrm>
+          <a:prstGeom prst="rect">
+            <a:avLst/>
+          </a:prstGeom>
+          <a:noFill/>
+          <a:ln/>
+        </p:spPr>
+        <p:txBody>
+          <a:bodyPr wrap="square" lIns="0" tIns="0" rIns="0" bIns="0" rtlCol="0" anchor="t">
+            <a:noAutofit/>
+          </a:bodyPr>
+          <a:lstStyle/>
+          <a:p>
+            <a:pPr marL="0" indent="0">
+              <a:buNone/>
+            </a:pPr>
+            <a:r>
+              <a:rPr lang="en-US" sz="700" dirty="0">
+                <a:solidFill>
+                  <a:srgbClr val="111111"/>
+                </a:solidFill>
+                <a:latin typeface="Courier New" pitchFamily="34" charset="0"/>
+                <a:ea typeface="Courier New" pitchFamily="34" charset="-122"/>
+                <a:cs typeface="Courier New" pitchFamily="34" charset="-120"/>
+              </a:rPr>
+              <a:t>&lt;?import </a:t>
+            </a:r>
+            <a:r>
+              <a:rPr lang="en-US" sz="700" dirty="0" err="1">
+                <a:solidFill>
+                  <a:srgbClr val="111111"/>
+                </a:solidFill>
+                <a:latin typeface="Courier New" pitchFamily="34" charset="0"/>
+                <a:ea typeface="Courier New" pitchFamily="34" charset="-122"/>
+                <a:cs typeface="Courier New" pitchFamily="34" charset="-120"/>
+              </a:rPr>
+              <a:t>javafx.scene.control.Button</a:t>
+            </a:r>
+            <a:r>
+              <a:rPr lang="en-US" sz="700" dirty="0">
+                <a:solidFill>
+                  <a:srgbClr val="111111"/>
+                </a:solidFill>
+                <a:latin typeface="Courier New" pitchFamily="34" charset="0"/>
+                <a:ea typeface="Courier New" pitchFamily="34" charset="-122"/>
+                <a:cs typeface="Courier New" pitchFamily="34" charset="-120"/>
+              </a:rPr>
+              <a:t>?&gt;</a:t>
+            </a:r>
+            <a:endParaRPr lang="en-US" sz="700" dirty="0"/>
+          </a:p>
+          <a:p>
+            <a:pPr marL="0" indent="0">
+              <a:buNone/>
+            </a:pPr>
+            <a:r>
+              <a:rPr lang="en-US" sz="700" dirty="0">
+                <a:solidFill>
+                  <a:srgbClr val="111111"/>
+                </a:solidFill>
+                <a:latin typeface="Courier New" pitchFamily="34" charset="0"/>
+                <a:ea typeface="Courier New" pitchFamily="34" charset="-122"/>
+                <a:cs typeface="Courier New" pitchFamily="34" charset="-120"/>
+              </a:rPr>
+              <a:t>&lt;?import javafx.scene.layout.VBox?&gt;</a:t>
+            </a:r>
+            <a:endParaRPr lang="en-US" sz="700" dirty="0"/>
+          </a:p>
+          <a:p>
+            <a:pPr marL="0" indent="0">
+              <a:buNone/>
+            </a:pPr>
+            <a:endParaRPr lang="en-US" sz="700" dirty="0"/>
+          </a:p>
+          <a:p>
+            <a:pPr marL="0" indent="0">
+              <a:buNone/>
+            </a:pPr>
+            <a:r>
+              <a:rPr lang="en-US" sz="700" dirty="0">
+                <a:solidFill>
+                  <a:srgbClr val="111111"/>
+                </a:solidFill>
+                <a:latin typeface="Courier New" pitchFamily="34" charset="0"/>
+                <a:ea typeface="Courier New" pitchFamily="34" charset="-122"/>
+                <a:cs typeface="Courier New" pitchFamily="34" charset="-120"/>
+              </a:rPr>
+              <a:t>&lt;VBox spacing="10" alignment="CENTER"</a:t>
+            </a:r>
+            <a:endParaRPr lang="en-US" sz="700" dirty="0"/>
+          </a:p>
+          <a:p>
+            <a:pPr marL="0" indent="0">
+              <a:buNone/>
+            </a:pPr>
+            <a:r>
+              <a:rPr lang="en-US" sz="700" dirty="0">
+                <a:solidFill>
+                  <a:srgbClr val="111111"/>
+                </a:solidFill>
+                <a:latin typeface="Courier New" pitchFamily="34" charset="0"/>
+                <a:ea typeface="Courier New" pitchFamily="34" charset="-122"/>
+                <a:cs typeface="Courier New" pitchFamily="34" charset="-120"/>
+              </a:rPr>
+              <a:t>     </a:t>
+            </a:r>
+            <a:r>
+              <a:rPr lang="en-US" sz="700" dirty="0" err="1">
+                <a:solidFill>
+                  <a:srgbClr val="111111"/>
+                </a:solidFill>
+                <a:latin typeface="Courier New" pitchFamily="34" charset="0"/>
+                <a:ea typeface="Courier New" pitchFamily="34" charset="-122"/>
+                <a:cs typeface="Courier New" pitchFamily="34" charset="-120"/>
+              </a:rPr>
+              <a:t>xmlns:fx</a:t>
+            </a:r>
+            <a:r>
+              <a:rPr lang="en-US" sz="700" dirty="0">
+                <a:solidFill>
+                  <a:srgbClr val="111111"/>
+                </a:solidFill>
+                <a:latin typeface="Courier New" pitchFamily="34" charset="0"/>
+                <a:ea typeface="Courier New" pitchFamily="34" charset="-122"/>
+                <a:cs typeface="Courier New" pitchFamily="34" charset="-120"/>
+              </a:rPr>
+              <a:t>="http://javafx.com/fxml"</a:t>
+            </a:r>
+            <a:endParaRPr lang="en-US" sz="700" dirty="0"/>
+          </a:p>
+          <a:p>
+            <a:pPr marL="0" indent="0">
+              <a:buNone/>
+            </a:pPr>
+            <a:r>
+              <a:rPr lang="en-US" sz="700" dirty="0">
+                <a:solidFill>
+                  <a:srgbClr val="111111"/>
+                </a:solidFill>
+                <a:latin typeface="Courier New" pitchFamily="34" charset="0"/>
+                <a:ea typeface="Courier New" pitchFamily="34" charset="-122"/>
+                <a:cs typeface="Courier New" pitchFamily="34" charset="-120"/>
+              </a:rPr>
+              <a:t>      fx:controller="Controller"&gt;</a:t>
+            </a:r>
+            <a:endParaRPr lang="en-US" sz="700" dirty="0"/>
+          </a:p>
+          <a:p>
+            <a:pPr marL="0" indent="0">
+              <a:buNone/>
+            </a:pPr>
+            <a:endParaRPr lang="en-US" sz="700" dirty="0"/>
+          </a:p>
+          <a:p>
+            <a:pPr marL="0" indent="0">
+              <a:buNone/>
+            </a:pPr>
+            <a:r>
+              <a:rPr lang="en-US" sz="700" dirty="0">
+                <a:solidFill>
+                  <a:srgbClr val="111111"/>
+                </a:solidFill>
+                <a:latin typeface="Courier New" pitchFamily="34" charset="0"/>
+                <a:ea typeface="Courier New" pitchFamily="34" charset="-122"/>
+                <a:cs typeface="Courier New" pitchFamily="34" charset="-120"/>
+              </a:rPr>
+              <a:t>  &lt;Button fx:id="loginButton"</a:t>
+            </a:r>
+            <a:endParaRPr lang="en-US" sz="700" dirty="0"/>
+          </a:p>
+          <a:p>
+            <a:pPr marL="0" indent="0">
+              <a:buNone/>
+            </a:pPr>
+            <a:r>
+              <a:rPr lang="en-US" sz="700" dirty="0">
+                <a:solidFill>
+                  <a:srgbClr val="111111"/>
+                </a:solidFill>
+                <a:latin typeface="Courier New" pitchFamily="34" charset="0"/>
+                <a:ea typeface="Courier New" pitchFamily="34" charset="-122"/>
+                <a:cs typeface="Courier New" pitchFamily="34" charset="-120"/>
+              </a:rPr>
+              <a:t>          text="Sign In"</a:t>
+            </a:r>
+            <a:endParaRPr lang="en-US" sz="700" dirty="0"/>
+          </a:p>
+          <a:p>
+            <a:pPr marL="0" indent="0">
+              <a:buNone/>
+            </a:pPr>
+            <a:r>
+              <a:rPr lang="en-US" sz="700" dirty="0">
+                <a:solidFill>
+                  <a:srgbClr val="111111"/>
+                </a:solidFill>
+                <a:latin typeface="Courier New" pitchFamily="34" charset="0"/>
+                <a:ea typeface="Courier New" pitchFamily="34" charset="-122"/>
+                <a:cs typeface="Courier New" pitchFamily="34" charset="-120"/>
+              </a:rPr>
+              <a:t>          onAction="#handleLogin"</a:t>
+            </a:r>
+            <a:endParaRPr lang="en-US" sz="700" dirty="0"/>
+          </a:p>
+          <a:p>
+            <a:pPr marL="0" indent="0">
+              <a:buNone/>
+            </a:pPr>
+            <a:r>
+              <a:rPr lang="en-US" sz="700" dirty="0">
+                <a:solidFill>
+                  <a:srgbClr val="111111"/>
+                </a:solidFill>
+                <a:latin typeface="Courier New" pitchFamily="34" charset="0"/>
+                <a:ea typeface="Courier New" pitchFamily="34" charset="-122"/>
+                <a:cs typeface="Courier New" pitchFamily="34" charset="-120"/>
+              </a:rPr>
+              <a:t>          styleClass="primary"/&gt;</a:t>
+            </a:r>
+            <a:endParaRPr lang="en-US" sz="700" dirty="0"/>
+          </a:p>
+          <a:p>
+            <a:pPr marL="0" indent="0">
+              <a:buNone/>
+            </a:pPr>
+            <a:endParaRPr lang="en-US" sz="700" dirty="0"/>
+          </a:p>
+          <a:p>
+            <a:pPr marL="0" indent="0">
+              <a:buNone/>
+            </a:pPr>
+            <a:r>
+              <a:rPr lang="en-US" sz="700" dirty="0">
+                <a:solidFill>
+                  <a:srgbClr val="111111"/>
+                </a:solidFill>
+                <a:latin typeface="Courier New" pitchFamily="34" charset="0"/>
+                <a:ea typeface="Courier New" pitchFamily="34" charset="-122"/>
+                <a:cs typeface="Courier New" pitchFamily="34" charset="-120"/>
+              </a:rPr>
+              <a:t>  &lt;stylesheets&gt;</a:t>
+            </a:r>
+            <a:endParaRPr lang="en-US" sz="700" dirty="0"/>
+          </a:p>
+          <a:p>
+            <a:pPr marL="0" indent="0">
+              <a:buNone/>
+            </a:pPr>
+            <a:r>
+              <a:rPr lang="en-US" sz="700" dirty="0">
+                <a:solidFill>
+                  <a:srgbClr val="111111"/>
+                </a:solidFill>
+                <a:latin typeface="Courier New" pitchFamily="34" charset="0"/>
+                <a:ea typeface="Courier New" pitchFamily="34" charset="-122"/>
+                <a:cs typeface="Courier New" pitchFamily="34" charset="-120"/>
+              </a:rPr>
+              <a:t>    &lt;URL value="@login.css"/&gt;</a:t>
+            </a:r>
+            <a:endParaRPr lang="en-US" sz="700" dirty="0"/>
+          </a:p>
+          <a:p>
+            <a:pPr marL="0" indent="0">
+              <a:buNone/>
+            </a:pPr>
+            <a:r>
+              <a:rPr lang="en-US" sz="700" dirty="0">
+                <a:solidFill>
+                  <a:srgbClr val="111111"/>
+                </a:solidFill>
+                <a:latin typeface="Courier New" pitchFamily="34" charset="0"/>
+                <a:ea typeface="Courier New" pitchFamily="34" charset="-122"/>
+                <a:cs typeface="Courier New" pitchFamily="34" charset="-120"/>
+              </a:rPr>
+              <a:t>  &lt;/stylesheets&gt;</a:t>
+            </a:r>
+            <a:endParaRPr lang="en-US" sz="700" dirty="0"/>
+          </a:p>
+          <a:p>
+            <a:pPr marL="0" indent="0">
+              <a:buNone/>
+            </a:pPr>
+            <a:r>
+              <a:rPr lang="en-US" sz="700" dirty="0">
+                <a:solidFill>
+                  <a:srgbClr val="111111"/>
+                </a:solidFill>
+                <a:latin typeface="Courier New" pitchFamily="34" charset="0"/>
+                <a:ea typeface="Courier New" pitchFamily="34" charset="-122"/>
+                <a:cs typeface="Courier New" pitchFamily="34" charset="-120"/>
+              </a:rPr>
+              <a:t>&lt;/VBox&gt;</a:t>
+            </a:r>
+            <a:endParaRPr lang="en-US" sz="700" dirty="0"/>
+          </a:p>
+        </p:txBody>
+      </p:sp>
+      <p:sp>
+        <p:nvSpPr>
+          <p:cNvPr id="17" name="Text 14">
+            <a:extLst>
+              <a:ext uri="{FF2B5EF4-FFF2-40B4-BE49-F238E27FC236}">
+                <a16:creationId xmlns:a16="http://schemas.microsoft.com/office/drawing/2014/main" id="{C32E29AB-F548-4BAD-47BF-61569B3BBC5A}"/>
+              </a:ext>
+            </a:extLst>
+          </p:cNvPr>
+          <p:cNvSpPr/>
+          <p:nvPr/>
+        </p:nvSpPr>
+        <p:spPr>
+          <a:xfrm>
+            <a:off x="6739128" y="3336120"/>
+            <a:ext cx="2112264" cy="219456"/>
+          </a:xfrm>
+          <a:prstGeom prst="rect">
+            <a:avLst/>
+          </a:prstGeom>
+          <a:noFill/>
+          <a:ln/>
+        </p:spPr>
+        <p:txBody>
+          <a:bodyPr wrap="square" lIns="127" tIns="127" rIns="127" bIns="127" rtlCol="0" anchor="ctr">
+            <a:normAutofit fontScale="85000" lnSpcReduction="20000"/>
+          </a:bodyPr>
+          <a:lstStyle/>
+          <a:p>
+            <a:pPr marL="0" indent="0" algn="ctr">
+              <a:buNone/>
+            </a:pPr>
+            <a:r>
+              <a:rPr lang="en-US" sz="920" dirty="0">
+                <a:solidFill>
+                  <a:srgbClr val="12984B"/>
+                </a:solidFill>
+              </a:rPr>
+              <a:t>Defines the UI structure and connects to controller and CSS</a:t>
+            </a:r>
+            <a:endParaRPr lang="en-US" sz="920" dirty="0"/>
+          </a:p>
+        </p:txBody>
+      </p:sp>
+      <p:sp>
+        <p:nvSpPr>
+          <p:cNvPr id="18" name="Shape 15">
+            <a:extLst>
+              <a:ext uri="{FF2B5EF4-FFF2-40B4-BE49-F238E27FC236}">
+                <a16:creationId xmlns:a16="http://schemas.microsoft.com/office/drawing/2014/main" id="{AA00EE1F-8965-7AD1-A154-F27263FF2C52}"/>
+              </a:ext>
+            </a:extLst>
+          </p:cNvPr>
+          <p:cNvSpPr/>
+          <p:nvPr/>
+        </p:nvSpPr>
+        <p:spPr>
+          <a:xfrm>
+            <a:off x="3221735" y="1572768"/>
+            <a:ext cx="2039111" cy="2212848"/>
+          </a:xfrm>
+          <a:prstGeom prst="roundRect">
+            <a:avLst>
+              <a:gd name="adj" fmla="val 3902"/>
+            </a:avLst>
+          </a:prstGeom>
+          <a:solidFill>
+            <a:srgbClr val="FFF4E6"/>
+          </a:solidFill>
+          <a:ln w="17780">
+            <a:solidFill>
+              <a:srgbClr val="F27616"/>
+            </a:solidFill>
+            <a:prstDash val="solid"/>
+          </a:ln>
+          <a:effectLst>
+            <a:outerShdw blurRad="19050" dist="7620" dir="2700000" algn="bl" rotWithShape="0">
+              <a:srgbClr val="000000">
+                <a:alpha val="10000"/>
+              </a:srgbClr>
+            </a:outerShdw>
+          </a:effectLst>
+        </p:spPr>
+        <p:txBody>
+          <a:bodyPr/>
+          <a:lstStyle/>
+          <a:p>
+            <a:endParaRPr lang="en-US"/>
+          </a:p>
+        </p:txBody>
+      </p:sp>
+      <p:sp>
+        <p:nvSpPr>
+          <p:cNvPr id="19" name="Text 16">
+            <a:extLst>
+              <a:ext uri="{FF2B5EF4-FFF2-40B4-BE49-F238E27FC236}">
+                <a16:creationId xmlns:a16="http://schemas.microsoft.com/office/drawing/2014/main" id="{2CD09467-1206-6B88-667A-99AE42CEC703}"/>
+              </a:ext>
+            </a:extLst>
+          </p:cNvPr>
+          <p:cNvSpPr/>
+          <p:nvPr/>
+        </p:nvSpPr>
+        <p:spPr>
+          <a:xfrm>
+            <a:off x="3331464" y="1682496"/>
+            <a:ext cx="256032" cy="228600"/>
+          </a:xfrm>
+          <a:prstGeom prst="rect">
+            <a:avLst/>
+          </a:prstGeom>
+          <a:noFill/>
+          <a:ln/>
+        </p:spPr>
+        <p:txBody>
+          <a:bodyPr wrap="square" lIns="0" tIns="0" rIns="0" bIns="0" rtlCol="0" anchor="ctr"/>
+          <a:lstStyle/>
+          <a:p>
+            <a:pPr marL="0" indent="0" algn="ctr">
+              <a:buNone/>
+            </a:pPr>
+            <a:endParaRPr lang="en-US" sz="1800" dirty="0"/>
+          </a:p>
+        </p:txBody>
+      </p:sp>
+      <p:sp>
+        <p:nvSpPr>
+          <p:cNvPr id="20" name="Text 17">
+            <a:extLst>
+              <a:ext uri="{FF2B5EF4-FFF2-40B4-BE49-F238E27FC236}">
+                <a16:creationId xmlns:a16="http://schemas.microsoft.com/office/drawing/2014/main" id="{54B06C37-85CB-2A18-30F4-7B083D9E88E5}"/>
+              </a:ext>
+            </a:extLst>
+          </p:cNvPr>
+          <p:cNvSpPr/>
+          <p:nvPr/>
+        </p:nvSpPr>
+        <p:spPr>
+          <a:xfrm>
+            <a:off x="3678936" y="1655064"/>
+            <a:ext cx="1490470" cy="228600"/>
+          </a:xfrm>
+          <a:prstGeom prst="rect">
+            <a:avLst/>
+          </a:prstGeom>
+          <a:noFill/>
+          <a:ln/>
+        </p:spPr>
+        <p:txBody>
+          <a:bodyPr wrap="square" lIns="127" tIns="127" rIns="127" bIns="127" rtlCol="0" anchor="ctr">
+            <a:normAutofit lnSpcReduction="10000"/>
+          </a:bodyPr>
+          <a:lstStyle/>
+          <a:p>
+            <a:pPr marL="0" indent="0">
+              <a:buNone/>
+            </a:pPr>
+            <a:r>
+              <a:rPr lang="en-US" sz="1600" b="1" dirty="0">
+                <a:solidFill>
+                  <a:srgbClr val="F27616"/>
+                </a:solidFill>
+              </a:rPr>
+              <a:t>Controller.java</a:t>
+            </a:r>
+            <a:endParaRPr lang="en-US" sz="1600" dirty="0"/>
+          </a:p>
+        </p:txBody>
+      </p:sp>
+      <p:sp>
+        <p:nvSpPr>
+          <p:cNvPr id="21" name="Text 18">
+            <a:extLst>
+              <a:ext uri="{FF2B5EF4-FFF2-40B4-BE49-F238E27FC236}">
+                <a16:creationId xmlns:a16="http://schemas.microsoft.com/office/drawing/2014/main" id="{43F26ACF-B0D3-8E04-14F5-452B991C4181}"/>
+              </a:ext>
+            </a:extLst>
+          </p:cNvPr>
+          <p:cNvSpPr/>
+          <p:nvPr/>
+        </p:nvSpPr>
+        <p:spPr>
+          <a:xfrm>
+            <a:off x="3678936" y="1920240"/>
+            <a:ext cx="1307592" cy="164592"/>
+          </a:xfrm>
+          <a:prstGeom prst="rect">
+            <a:avLst/>
+          </a:prstGeom>
+          <a:noFill/>
+          <a:ln/>
+        </p:spPr>
+        <p:txBody>
+          <a:bodyPr wrap="square" lIns="127" tIns="127" rIns="127" bIns="127" rtlCol="0" anchor="ctr">
+            <a:normAutofit/>
+          </a:bodyPr>
+          <a:lstStyle/>
+          <a:p>
+            <a:pPr marL="0" indent="0">
+              <a:buNone/>
+            </a:pPr>
+            <a:r>
+              <a:rPr lang="en-US" sz="880" dirty="0">
+                <a:solidFill>
+                  <a:srgbClr val="F27616"/>
+                </a:solidFill>
+              </a:rPr>
+              <a:t>(Handles user behavior)</a:t>
+            </a:r>
+            <a:endParaRPr lang="en-US" sz="880" dirty="0"/>
+          </a:p>
+        </p:txBody>
+      </p:sp>
+      <p:sp>
+        <p:nvSpPr>
+          <p:cNvPr id="22" name="Shape 19">
+            <a:extLst>
+              <a:ext uri="{FF2B5EF4-FFF2-40B4-BE49-F238E27FC236}">
+                <a16:creationId xmlns:a16="http://schemas.microsoft.com/office/drawing/2014/main" id="{861FCE34-36F7-165D-ADD4-733F654D1863}"/>
+              </a:ext>
+            </a:extLst>
+          </p:cNvPr>
+          <p:cNvSpPr/>
+          <p:nvPr/>
+        </p:nvSpPr>
+        <p:spPr>
+          <a:xfrm>
+            <a:off x="3313176" y="2103120"/>
+            <a:ext cx="1837942" cy="1389888"/>
+          </a:xfrm>
+          <a:prstGeom prst="roundRect">
+            <a:avLst>
+              <a:gd name="adj" fmla="val 3289"/>
+            </a:avLst>
+          </a:prstGeom>
+          <a:solidFill>
+            <a:srgbClr val="FFFFFF">
+              <a:alpha val="96000"/>
+            </a:srgbClr>
+          </a:solidFill>
+          <a:ln w="8890">
+            <a:solidFill>
+              <a:srgbClr val="D9E2EA"/>
+            </a:solidFill>
+            <a:prstDash val="solid"/>
+          </a:ln>
+        </p:spPr>
+        <p:txBody>
+          <a:bodyPr/>
+          <a:lstStyle/>
+          <a:p>
+            <a:endParaRPr lang="en-US"/>
+          </a:p>
+        </p:txBody>
+      </p:sp>
+      <p:sp>
+        <p:nvSpPr>
+          <p:cNvPr id="23" name="Text 20">
+            <a:extLst>
+              <a:ext uri="{FF2B5EF4-FFF2-40B4-BE49-F238E27FC236}">
+                <a16:creationId xmlns:a16="http://schemas.microsoft.com/office/drawing/2014/main" id="{C493EBE9-10E5-16DD-4FCE-A8FA1AB438C1}"/>
+              </a:ext>
+            </a:extLst>
+          </p:cNvPr>
+          <p:cNvSpPr/>
+          <p:nvPr/>
+        </p:nvSpPr>
+        <p:spPr>
+          <a:xfrm>
+            <a:off x="3372612" y="2119251"/>
+            <a:ext cx="1796794" cy="1280160"/>
+          </a:xfrm>
+          <a:prstGeom prst="rect">
+            <a:avLst/>
+          </a:prstGeom>
+          <a:noFill/>
+          <a:ln/>
+        </p:spPr>
+        <p:txBody>
+          <a:bodyPr wrap="square" lIns="0" tIns="0" rIns="0" bIns="0" rtlCol="0" anchor="t">
+            <a:noAutofit/>
+          </a:bodyPr>
+          <a:lstStyle/>
+          <a:p>
+            <a:pPr marL="0" indent="0">
+              <a:buNone/>
+            </a:pPr>
+            <a:r>
+              <a:rPr lang="en-US" sz="700" dirty="0">
+                <a:solidFill>
+                  <a:srgbClr val="111111"/>
+                </a:solidFill>
+                <a:latin typeface="Courier New" pitchFamily="34" charset="0"/>
+                <a:ea typeface="Courier New" pitchFamily="34" charset="-122"/>
+                <a:cs typeface="Courier New" pitchFamily="34" charset="-120"/>
+              </a:rPr>
+              <a:t>public class Controller {</a:t>
+            </a:r>
+            <a:endParaRPr lang="en-US" sz="700" dirty="0"/>
+          </a:p>
+          <a:p>
+            <a:pPr marL="0" indent="0">
+              <a:buNone/>
+            </a:pPr>
+            <a:r>
+              <a:rPr lang="en-US" sz="700" dirty="0">
+                <a:solidFill>
+                  <a:srgbClr val="111111"/>
+                </a:solidFill>
+                <a:latin typeface="Courier New" pitchFamily="34" charset="0"/>
+                <a:ea typeface="Courier New" pitchFamily="34" charset="-122"/>
+                <a:cs typeface="Courier New" pitchFamily="34" charset="-120"/>
+              </a:rPr>
+              <a:t>  @FXML</a:t>
+            </a:r>
+            <a:endParaRPr lang="en-US" sz="700" dirty="0"/>
+          </a:p>
+          <a:p>
+            <a:pPr marL="0" indent="0">
+              <a:buNone/>
+            </a:pPr>
+            <a:r>
+              <a:rPr lang="en-US" sz="700" dirty="0">
+                <a:solidFill>
+                  <a:srgbClr val="111111"/>
+                </a:solidFill>
+                <a:latin typeface="Courier New" pitchFamily="34" charset="0"/>
+                <a:ea typeface="Courier New" pitchFamily="34" charset="-122"/>
+                <a:cs typeface="Courier New" pitchFamily="34" charset="-120"/>
+              </a:rPr>
+              <a:t>  private Button loginButton;</a:t>
+            </a:r>
+            <a:endParaRPr lang="en-US" sz="700" dirty="0"/>
+          </a:p>
+          <a:p>
+            <a:pPr marL="0" indent="0">
+              <a:buNone/>
+            </a:pPr>
+            <a:endParaRPr lang="en-US" sz="700" dirty="0"/>
+          </a:p>
+          <a:p>
+            <a:pPr marL="0" indent="0">
+              <a:buNone/>
+            </a:pPr>
+            <a:r>
+              <a:rPr lang="en-US" sz="700" dirty="0">
+                <a:solidFill>
+                  <a:srgbClr val="111111"/>
+                </a:solidFill>
+                <a:latin typeface="Courier New" pitchFamily="34" charset="0"/>
+                <a:ea typeface="Courier New" pitchFamily="34" charset="-122"/>
+                <a:cs typeface="Courier New" pitchFamily="34" charset="-120"/>
+              </a:rPr>
+              <a:t>  @FXML</a:t>
+            </a:r>
+            <a:endParaRPr lang="en-US" sz="700" dirty="0"/>
+          </a:p>
+          <a:p>
+            <a:pPr marL="0" indent="0">
+              <a:buNone/>
+            </a:pPr>
+            <a:r>
+              <a:rPr lang="en-US" sz="700" dirty="0">
+                <a:solidFill>
+                  <a:srgbClr val="111111"/>
+                </a:solidFill>
+                <a:latin typeface="Courier New" pitchFamily="34" charset="0"/>
+                <a:ea typeface="Courier New" pitchFamily="34" charset="-122"/>
+                <a:cs typeface="Courier New" pitchFamily="34" charset="-120"/>
+              </a:rPr>
+              <a:t>  private void handleLogin(</a:t>
+            </a:r>
+            <a:endParaRPr lang="en-US" sz="700" dirty="0"/>
+          </a:p>
+          <a:p>
+            <a:pPr marL="0" indent="0">
+              <a:buNone/>
+            </a:pPr>
+            <a:r>
+              <a:rPr lang="en-US" sz="700" dirty="0">
+                <a:solidFill>
+                  <a:srgbClr val="111111"/>
+                </a:solidFill>
+                <a:latin typeface="Courier New" pitchFamily="34" charset="0"/>
+                <a:ea typeface="Courier New" pitchFamily="34" charset="-122"/>
+                <a:cs typeface="Courier New" pitchFamily="34" charset="-120"/>
+              </a:rPr>
+              <a:t>      ActionEvent event) {</a:t>
+            </a:r>
+            <a:endParaRPr lang="en-US" sz="700" dirty="0"/>
+          </a:p>
+          <a:p>
+            <a:pPr marL="0" indent="0">
+              <a:buNone/>
+            </a:pPr>
+            <a:r>
+              <a:rPr lang="en-US" sz="700" dirty="0">
+                <a:solidFill>
+                  <a:srgbClr val="111111"/>
+                </a:solidFill>
+                <a:latin typeface="Courier New" pitchFamily="34" charset="0"/>
+                <a:ea typeface="Courier New" pitchFamily="34" charset="-122"/>
+                <a:cs typeface="Courier New" pitchFamily="34" charset="-120"/>
+              </a:rPr>
+              <a:t>    System.out.println(</a:t>
+            </a:r>
+            <a:endParaRPr lang="en-US" sz="700" dirty="0"/>
+          </a:p>
+          <a:p>
+            <a:pPr marL="0" indent="0">
+              <a:buNone/>
+            </a:pPr>
+            <a:r>
+              <a:rPr lang="en-US" sz="700" dirty="0">
+                <a:solidFill>
+                  <a:srgbClr val="111111"/>
+                </a:solidFill>
+                <a:latin typeface="Courier New" pitchFamily="34" charset="0"/>
+                <a:ea typeface="Courier New" pitchFamily="34" charset="-122"/>
+                <a:cs typeface="Courier New" pitchFamily="34" charset="-120"/>
+              </a:rPr>
+              <a:t>      "Login button clicked!");</a:t>
+            </a:r>
+            <a:endParaRPr lang="en-US" sz="700" dirty="0"/>
+          </a:p>
+          <a:p>
+            <a:pPr marL="0" indent="0">
+              <a:buNone/>
+            </a:pPr>
+            <a:r>
+              <a:rPr lang="en-US" sz="700" dirty="0">
+                <a:solidFill>
+                  <a:srgbClr val="111111"/>
+                </a:solidFill>
+                <a:latin typeface="Courier New" pitchFamily="34" charset="0"/>
+                <a:ea typeface="Courier New" pitchFamily="34" charset="-122"/>
+                <a:cs typeface="Courier New" pitchFamily="34" charset="-120"/>
+              </a:rPr>
+              <a:t>  }</a:t>
+            </a:r>
+            <a:endParaRPr lang="en-US" sz="700" dirty="0"/>
+          </a:p>
+          <a:p>
+            <a:pPr marL="0" indent="0">
+              <a:buNone/>
+            </a:pPr>
+            <a:r>
+              <a:rPr lang="en-US" sz="700" dirty="0">
+                <a:solidFill>
+                  <a:srgbClr val="111111"/>
+                </a:solidFill>
+                <a:latin typeface="Courier New" pitchFamily="34" charset="0"/>
+                <a:ea typeface="Courier New" pitchFamily="34" charset="-122"/>
+                <a:cs typeface="Courier New" pitchFamily="34" charset="-120"/>
+              </a:rPr>
+              <a:t>}</a:t>
+            </a:r>
+            <a:endParaRPr lang="en-US" sz="700" dirty="0"/>
+          </a:p>
+        </p:txBody>
+      </p:sp>
+      <p:sp>
+        <p:nvSpPr>
+          <p:cNvPr id="24" name="Text 21">
+            <a:extLst>
+              <a:ext uri="{FF2B5EF4-FFF2-40B4-BE49-F238E27FC236}">
+                <a16:creationId xmlns:a16="http://schemas.microsoft.com/office/drawing/2014/main" id="{D40D4A17-5350-09BE-7F23-515AC0ACBA91}"/>
+              </a:ext>
+            </a:extLst>
+          </p:cNvPr>
+          <p:cNvSpPr/>
+          <p:nvPr/>
+        </p:nvSpPr>
+        <p:spPr>
+          <a:xfrm>
+            <a:off x="3331464" y="3493008"/>
+            <a:ext cx="1655064" cy="219456"/>
+          </a:xfrm>
+          <a:prstGeom prst="rect">
+            <a:avLst/>
+          </a:prstGeom>
+          <a:noFill/>
+          <a:ln/>
+        </p:spPr>
+        <p:txBody>
+          <a:bodyPr wrap="square" lIns="127" tIns="127" rIns="127" bIns="127" rtlCol="0" anchor="ctr">
+            <a:normAutofit/>
+          </a:bodyPr>
+          <a:lstStyle/>
+          <a:p>
+            <a:pPr marL="0" indent="0" algn="ctr">
+              <a:buNone/>
+            </a:pPr>
+            <a:r>
+              <a:rPr lang="en-US" sz="920" dirty="0">
+                <a:solidFill>
+                  <a:srgbClr val="F27616"/>
+                </a:solidFill>
+              </a:rPr>
+              <a:t>Processes user actions</a:t>
+            </a:r>
+            <a:endParaRPr lang="en-US" sz="920" dirty="0"/>
+          </a:p>
+        </p:txBody>
+      </p:sp>
+      <p:sp>
+        <p:nvSpPr>
+          <p:cNvPr id="25" name="Shape 22">
+            <a:extLst>
+              <a:ext uri="{FF2B5EF4-FFF2-40B4-BE49-F238E27FC236}">
+                <a16:creationId xmlns:a16="http://schemas.microsoft.com/office/drawing/2014/main" id="{74BBEB32-07C5-C5D8-F8AB-68D4334F7B14}"/>
+              </a:ext>
+            </a:extLst>
+          </p:cNvPr>
+          <p:cNvSpPr/>
+          <p:nvPr/>
+        </p:nvSpPr>
+        <p:spPr>
+          <a:xfrm>
+            <a:off x="228600" y="4297680"/>
+            <a:ext cx="3995351" cy="2011680"/>
+          </a:xfrm>
+          <a:prstGeom prst="roundRect">
+            <a:avLst>
+              <a:gd name="adj" fmla="val 3636"/>
+            </a:avLst>
+          </a:prstGeom>
+          <a:solidFill>
+            <a:srgbClr val="F1EAFF"/>
+          </a:solidFill>
+          <a:ln w="17780">
+            <a:solidFill>
+              <a:srgbClr val="7B49D6"/>
+            </a:solidFill>
+            <a:prstDash val="solid"/>
+          </a:ln>
+          <a:effectLst>
+            <a:outerShdw blurRad="15240" dist="6350" dir="2700000" algn="bl" rotWithShape="0">
+              <a:srgbClr val="000000">
+                <a:alpha val="8000"/>
+              </a:srgbClr>
+            </a:outerShdw>
+          </a:effectLst>
+        </p:spPr>
+        <p:txBody>
+          <a:bodyPr/>
+          <a:lstStyle/>
+          <a:p>
+            <a:endParaRPr lang="en-US"/>
+          </a:p>
+        </p:txBody>
+      </p:sp>
+      <p:sp>
+        <p:nvSpPr>
+          <p:cNvPr id="27" name="Text 24">
+            <a:extLst>
+              <a:ext uri="{FF2B5EF4-FFF2-40B4-BE49-F238E27FC236}">
+                <a16:creationId xmlns:a16="http://schemas.microsoft.com/office/drawing/2014/main" id="{24A3453B-D8CF-4BA9-C30A-D80CC478FE77}"/>
+              </a:ext>
+            </a:extLst>
+          </p:cNvPr>
+          <p:cNvSpPr/>
+          <p:nvPr/>
+        </p:nvSpPr>
+        <p:spPr>
+          <a:xfrm>
+            <a:off x="512982" y="4370832"/>
+            <a:ext cx="2977277" cy="219456"/>
+          </a:xfrm>
+          <a:prstGeom prst="rect">
+            <a:avLst/>
+          </a:prstGeom>
+          <a:noFill/>
+          <a:ln/>
+        </p:spPr>
+        <p:txBody>
+          <a:bodyPr wrap="square" lIns="127" tIns="127" rIns="127" bIns="127" rtlCol="0" anchor="ctr">
+            <a:normAutofit lnSpcReduction="10000"/>
+          </a:bodyPr>
+          <a:lstStyle/>
+          <a:p>
+            <a:pPr marL="0" indent="0">
+              <a:buNone/>
+            </a:pPr>
+            <a:r>
+              <a:rPr lang="en-US" sz="1580" b="1" dirty="0">
+                <a:solidFill>
+                  <a:srgbClr val="2F196E"/>
+                </a:solidFill>
+              </a:rPr>
+              <a:t>Runtime UI Window</a:t>
+            </a:r>
+            <a:endParaRPr lang="en-US" sz="1580" dirty="0"/>
+          </a:p>
+        </p:txBody>
+      </p:sp>
+      <p:sp>
+        <p:nvSpPr>
+          <p:cNvPr id="28" name="Text 25">
+            <a:extLst>
+              <a:ext uri="{FF2B5EF4-FFF2-40B4-BE49-F238E27FC236}">
+                <a16:creationId xmlns:a16="http://schemas.microsoft.com/office/drawing/2014/main" id="{650174D3-A6B3-DBA5-645C-E2253474568C}"/>
+              </a:ext>
+            </a:extLst>
+          </p:cNvPr>
+          <p:cNvSpPr/>
+          <p:nvPr/>
+        </p:nvSpPr>
+        <p:spPr>
+          <a:xfrm>
+            <a:off x="512982" y="4617720"/>
+            <a:ext cx="3657600" cy="155448"/>
+          </a:xfrm>
+          <a:prstGeom prst="rect">
+            <a:avLst/>
+          </a:prstGeom>
+          <a:noFill/>
+          <a:ln/>
+        </p:spPr>
+        <p:txBody>
+          <a:bodyPr wrap="square" lIns="127" tIns="127" rIns="127" bIns="127" rtlCol="0" anchor="ctr">
+            <a:normAutofit/>
+          </a:bodyPr>
+          <a:lstStyle/>
+          <a:p>
+            <a:pPr marL="0" indent="0">
+              <a:buNone/>
+            </a:pPr>
+            <a:r>
+              <a:rPr lang="en-US" sz="880" dirty="0">
+                <a:solidFill>
+                  <a:srgbClr val="2F196E"/>
+                </a:solidFill>
+              </a:rPr>
+              <a:t>(What the user sees)</a:t>
+            </a:r>
+            <a:endParaRPr lang="en-US" sz="880" dirty="0"/>
+          </a:p>
+        </p:txBody>
+      </p:sp>
+      <p:sp>
+        <p:nvSpPr>
+          <p:cNvPr id="29" name="Shape 26">
+            <a:extLst>
+              <a:ext uri="{FF2B5EF4-FFF2-40B4-BE49-F238E27FC236}">
+                <a16:creationId xmlns:a16="http://schemas.microsoft.com/office/drawing/2014/main" id="{F42B1C3A-4797-D115-9898-5CCD9E86E5FE}"/>
+              </a:ext>
+            </a:extLst>
+          </p:cNvPr>
+          <p:cNvSpPr/>
+          <p:nvPr/>
+        </p:nvSpPr>
+        <p:spPr>
+          <a:xfrm>
+            <a:off x="604422" y="4828032"/>
+            <a:ext cx="3154680" cy="1298448"/>
+          </a:xfrm>
+          <a:prstGeom prst="roundRect">
+            <a:avLst>
+              <a:gd name="adj" fmla="val 4225"/>
+            </a:avLst>
+          </a:prstGeom>
+          <a:solidFill>
+            <a:srgbClr val="FFFFFF"/>
+          </a:solidFill>
+          <a:ln w="10160">
+            <a:solidFill>
+              <a:srgbClr val="BFC7D1"/>
+            </a:solidFill>
+            <a:prstDash val="solid"/>
+          </a:ln>
+          <a:effectLst>
+            <a:outerShdw blurRad="19050" dist="10160" dir="2700000" algn="bl" rotWithShape="0">
+              <a:srgbClr val="000000">
+                <a:alpha val="12000"/>
+              </a:srgbClr>
+            </a:outerShdw>
+          </a:effectLst>
+        </p:spPr>
+        <p:txBody>
+          <a:bodyPr/>
+          <a:lstStyle/>
+          <a:p>
+            <a:endParaRPr lang="en-US"/>
+          </a:p>
+        </p:txBody>
+      </p:sp>
+      <p:sp>
+        <p:nvSpPr>
+          <p:cNvPr id="30" name="Shape 27">
+            <a:extLst>
+              <a:ext uri="{FF2B5EF4-FFF2-40B4-BE49-F238E27FC236}">
+                <a16:creationId xmlns:a16="http://schemas.microsoft.com/office/drawing/2014/main" id="{27CC98EA-42FA-C23E-ECFE-EB744258DCC3}"/>
+              </a:ext>
+            </a:extLst>
+          </p:cNvPr>
+          <p:cNvSpPr/>
+          <p:nvPr/>
+        </p:nvSpPr>
+        <p:spPr>
+          <a:xfrm>
+            <a:off x="604422" y="4828032"/>
+            <a:ext cx="3154680" cy="256032"/>
+          </a:xfrm>
+          <a:prstGeom prst="rect">
+            <a:avLst/>
+          </a:prstGeom>
+          <a:solidFill>
+            <a:srgbClr val="ECEFF4"/>
+          </a:solidFill>
+          <a:ln w="6350">
+            <a:solidFill>
+              <a:srgbClr val="BFC7D1"/>
+            </a:solidFill>
+            <a:prstDash val="solid"/>
+          </a:ln>
+        </p:spPr>
+        <p:txBody>
+          <a:bodyPr/>
+          <a:lstStyle/>
+          <a:p>
+            <a:endParaRPr lang="en-US"/>
+          </a:p>
+        </p:txBody>
+      </p:sp>
+      <p:sp>
+        <p:nvSpPr>
+          <p:cNvPr id="31" name="Shape 28">
+            <a:extLst>
+              <a:ext uri="{FF2B5EF4-FFF2-40B4-BE49-F238E27FC236}">
+                <a16:creationId xmlns:a16="http://schemas.microsoft.com/office/drawing/2014/main" id="{3CFA829B-95E4-8A52-19D7-6AEF6C5C0405}"/>
+              </a:ext>
+            </a:extLst>
+          </p:cNvPr>
+          <p:cNvSpPr/>
+          <p:nvPr/>
+        </p:nvSpPr>
+        <p:spPr>
+          <a:xfrm>
+            <a:off x="723294" y="4910328"/>
+            <a:ext cx="73152" cy="73152"/>
+          </a:xfrm>
+          <a:prstGeom prst="ellipse">
+            <a:avLst/>
+          </a:prstGeom>
+          <a:solidFill>
+            <a:srgbClr val="F25F5C"/>
+          </a:solidFill>
+          <a:ln w="12700">
+            <a:solidFill>
+              <a:srgbClr val="F25F5C"/>
+            </a:solidFill>
+            <a:prstDash val="solid"/>
+          </a:ln>
+        </p:spPr>
+        <p:txBody>
+          <a:bodyPr/>
+          <a:lstStyle/>
+          <a:p>
+            <a:endParaRPr lang="en-US"/>
+          </a:p>
+        </p:txBody>
+      </p:sp>
+      <p:sp>
+        <p:nvSpPr>
+          <p:cNvPr id="32" name="Shape 29">
+            <a:extLst>
+              <a:ext uri="{FF2B5EF4-FFF2-40B4-BE49-F238E27FC236}">
+                <a16:creationId xmlns:a16="http://schemas.microsoft.com/office/drawing/2014/main" id="{9E7C45B3-D1FB-DD92-0494-C02B75591357}"/>
+              </a:ext>
+            </a:extLst>
+          </p:cNvPr>
+          <p:cNvSpPr/>
+          <p:nvPr/>
+        </p:nvSpPr>
+        <p:spPr>
+          <a:xfrm>
+            <a:off x="860454" y="4910328"/>
+            <a:ext cx="73152" cy="73152"/>
+          </a:xfrm>
+          <a:prstGeom prst="ellipse">
+            <a:avLst/>
+          </a:prstGeom>
+          <a:solidFill>
+            <a:srgbClr val="FFBD4A"/>
+          </a:solidFill>
+          <a:ln w="12700">
+            <a:solidFill>
+              <a:srgbClr val="FFBD4A"/>
+            </a:solidFill>
+            <a:prstDash val="solid"/>
+          </a:ln>
+        </p:spPr>
+        <p:txBody>
+          <a:bodyPr/>
+          <a:lstStyle/>
+          <a:p>
+            <a:endParaRPr lang="en-US"/>
+          </a:p>
+        </p:txBody>
+      </p:sp>
+      <p:sp>
+        <p:nvSpPr>
+          <p:cNvPr id="33" name="Shape 30">
+            <a:extLst>
+              <a:ext uri="{FF2B5EF4-FFF2-40B4-BE49-F238E27FC236}">
+                <a16:creationId xmlns:a16="http://schemas.microsoft.com/office/drawing/2014/main" id="{F9271F76-743F-4783-B81F-7ED7403DD0EC}"/>
+              </a:ext>
+            </a:extLst>
+          </p:cNvPr>
+          <p:cNvSpPr/>
+          <p:nvPr/>
+        </p:nvSpPr>
+        <p:spPr>
+          <a:xfrm>
+            <a:off x="997614" y="4910328"/>
+            <a:ext cx="73152" cy="73152"/>
+          </a:xfrm>
+          <a:prstGeom prst="ellipse">
+            <a:avLst/>
+          </a:prstGeom>
+          <a:solidFill>
+            <a:srgbClr val="30C05B"/>
+          </a:solidFill>
+          <a:ln w="12700">
+            <a:solidFill>
+              <a:srgbClr val="30C05B"/>
+            </a:solidFill>
+            <a:prstDash val="solid"/>
+          </a:ln>
+        </p:spPr>
+        <p:txBody>
+          <a:bodyPr/>
+          <a:lstStyle/>
+          <a:p>
+            <a:endParaRPr lang="en-US"/>
+          </a:p>
+        </p:txBody>
+      </p:sp>
+      <p:sp>
+        <p:nvSpPr>
+          <p:cNvPr id="34" name="Text 31">
+            <a:extLst>
+              <a:ext uri="{FF2B5EF4-FFF2-40B4-BE49-F238E27FC236}">
+                <a16:creationId xmlns:a16="http://schemas.microsoft.com/office/drawing/2014/main" id="{4406823F-267A-A0F8-9ADD-7C31A7D8C49D}"/>
+              </a:ext>
+            </a:extLst>
+          </p:cNvPr>
+          <p:cNvSpPr/>
+          <p:nvPr/>
+        </p:nvSpPr>
+        <p:spPr>
+          <a:xfrm>
+            <a:off x="604422" y="4882896"/>
+            <a:ext cx="3154680" cy="146304"/>
+          </a:xfrm>
+          <a:prstGeom prst="rect">
+            <a:avLst/>
+          </a:prstGeom>
+          <a:noFill/>
+          <a:ln/>
+        </p:spPr>
+        <p:txBody>
+          <a:bodyPr wrap="square" lIns="0" tIns="0" rIns="0" bIns="0" rtlCol="0" anchor="ctr"/>
+          <a:lstStyle/>
+          <a:p>
+            <a:pPr marL="0" indent="0" algn="ctr">
+              <a:buNone/>
+            </a:pPr>
+            <a:r>
+              <a:rPr lang="en-US" sz="800" dirty="0">
+                <a:solidFill>
+                  <a:srgbClr val="111111"/>
+                </a:solidFill>
+              </a:rPr>
+              <a:t>My App</a:t>
+            </a:r>
+            <a:endParaRPr lang="en-US" sz="800" dirty="0"/>
+          </a:p>
+        </p:txBody>
+      </p:sp>
+      <p:sp>
+        <p:nvSpPr>
+          <p:cNvPr id="35" name="Text 32">
+            <a:extLst>
+              <a:ext uri="{FF2B5EF4-FFF2-40B4-BE49-F238E27FC236}">
+                <a16:creationId xmlns:a16="http://schemas.microsoft.com/office/drawing/2014/main" id="{677DC87D-5119-4130-F298-AF2CD7793EAA}"/>
+              </a:ext>
+            </a:extLst>
+          </p:cNvPr>
+          <p:cNvSpPr/>
+          <p:nvPr/>
+        </p:nvSpPr>
+        <p:spPr>
+          <a:xfrm>
+            <a:off x="924462" y="5184648"/>
+            <a:ext cx="685800" cy="164592"/>
+          </a:xfrm>
+          <a:prstGeom prst="rect">
+            <a:avLst/>
+          </a:prstGeom>
+          <a:noFill/>
+          <a:ln/>
+        </p:spPr>
+        <p:txBody>
+          <a:bodyPr wrap="square" lIns="0" tIns="0" rIns="0" bIns="0" rtlCol="0" anchor="ctr">
+            <a:normAutofit/>
+          </a:bodyPr>
+          <a:lstStyle/>
+          <a:p>
+            <a:pPr marL="0" indent="0">
+              <a:buNone/>
+            </a:pPr>
+            <a:r>
+              <a:rPr lang="en-US" sz="800" dirty="0">
+                <a:solidFill>
+                  <a:srgbClr val="111111"/>
+                </a:solidFill>
+              </a:rPr>
+              <a:t>Username:</a:t>
+            </a:r>
+            <a:endParaRPr lang="en-US" sz="800" dirty="0"/>
+          </a:p>
+        </p:txBody>
+      </p:sp>
+      <p:sp>
+        <p:nvSpPr>
+          <p:cNvPr id="36" name="Shape 33">
+            <a:extLst>
+              <a:ext uri="{FF2B5EF4-FFF2-40B4-BE49-F238E27FC236}">
+                <a16:creationId xmlns:a16="http://schemas.microsoft.com/office/drawing/2014/main" id="{7BCE766D-37EA-49A2-307F-23E94BC022BC}"/>
+              </a:ext>
+            </a:extLst>
+          </p:cNvPr>
+          <p:cNvSpPr/>
+          <p:nvPr/>
+        </p:nvSpPr>
+        <p:spPr>
+          <a:xfrm>
+            <a:off x="1701702" y="5157216"/>
+            <a:ext cx="1737360" cy="246888"/>
+          </a:xfrm>
+          <a:prstGeom prst="roundRect">
+            <a:avLst>
+              <a:gd name="adj" fmla="val 11111"/>
+            </a:avLst>
+          </a:prstGeom>
+          <a:solidFill>
+            <a:srgbClr val="FFFFFF"/>
+          </a:solidFill>
+          <a:ln w="10160">
+            <a:solidFill>
+              <a:srgbClr val="C5CDD5"/>
+            </a:solidFill>
+            <a:prstDash val="solid"/>
+          </a:ln>
+        </p:spPr>
+        <p:txBody>
+          <a:bodyPr/>
+          <a:lstStyle/>
+          <a:p>
+            <a:endParaRPr lang="en-US"/>
+          </a:p>
+        </p:txBody>
+      </p:sp>
+      <p:sp>
+        <p:nvSpPr>
+          <p:cNvPr id="37" name="Text 34">
+            <a:extLst>
+              <a:ext uri="{FF2B5EF4-FFF2-40B4-BE49-F238E27FC236}">
+                <a16:creationId xmlns:a16="http://schemas.microsoft.com/office/drawing/2014/main" id="{A6C40210-4A0B-A1C2-F473-C71AE8510F6D}"/>
+              </a:ext>
+            </a:extLst>
+          </p:cNvPr>
+          <p:cNvSpPr/>
+          <p:nvPr/>
+        </p:nvSpPr>
+        <p:spPr>
+          <a:xfrm>
+            <a:off x="1774854" y="5207508"/>
+            <a:ext cx="1600200" cy="118872"/>
+          </a:xfrm>
+          <a:prstGeom prst="rect">
+            <a:avLst/>
+          </a:prstGeom>
+          <a:noFill/>
+          <a:ln/>
+        </p:spPr>
+        <p:txBody>
+          <a:bodyPr wrap="square" lIns="0" tIns="0" rIns="0" bIns="0" rtlCol="0" anchor="ctr"/>
+          <a:lstStyle/>
+          <a:p>
+            <a:pPr marL="0" indent="0">
+              <a:buNone/>
+            </a:pPr>
+            <a:r>
+              <a:rPr lang="en-US" sz="750" dirty="0">
+                <a:solidFill>
+                  <a:srgbClr val="7A7A7A"/>
+                </a:solidFill>
+              </a:rPr>
+              <a:t>Enter username</a:t>
+            </a:r>
+            <a:endParaRPr lang="en-US" sz="750" dirty="0"/>
+          </a:p>
+        </p:txBody>
+      </p:sp>
+      <p:sp>
+        <p:nvSpPr>
+          <p:cNvPr id="38" name="Text 35">
+            <a:extLst>
+              <a:ext uri="{FF2B5EF4-FFF2-40B4-BE49-F238E27FC236}">
+                <a16:creationId xmlns:a16="http://schemas.microsoft.com/office/drawing/2014/main" id="{228F2B2C-2C53-2109-62C9-5B2A145719A2}"/>
+              </a:ext>
+            </a:extLst>
+          </p:cNvPr>
+          <p:cNvSpPr/>
+          <p:nvPr/>
+        </p:nvSpPr>
+        <p:spPr>
+          <a:xfrm>
+            <a:off x="924462" y="5468112"/>
+            <a:ext cx="685800" cy="164592"/>
+          </a:xfrm>
+          <a:prstGeom prst="rect">
+            <a:avLst/>
+          </a:prstGeom>
+          <a:noFill/>
+          <a:ln/>
+        </p:spPr>
+        <p:txBody>
+          <a:bodyPr wrap="square" lIns="0" tIns="0" rIns="0" bIns="0" rtlCol="0" anchor="ctr">
+            <a:normAutofit/>
+          </a:bodyPr>
+          <a:lstStyle/>
+          <a:p>
+            <a:pPr marL="0" indent="0">
+              <a:buNone/>
+            </a:pPr>
+            <a:r>
+              <a:rPr lang="en-US" sz="800" dirty="0">
+                <a:solidFill>
+                  <a:srgbClr val="111111"/>
+                </a:solidFill>
+              </a:rPr>
+              <a:t>Password:</a:t>
+            </a:r>
+            <a:endParaRPr lang="en-US" sz="800" dirty="0"/>
+          </a:p>
+        </p:txBody>
+      </p:sp>
+      <p:sp>
+        <p:nvSpPr>
+          <p:cNvPr id="39" name="Shape 36">
+            <a:extLst>
+              <a:ext uri="{FF2B5EF4-FFF2-40B4-BE49-F238E27FC236}">
+                <a16:creationId xmlns:a16="http://schemas.microsoft.com/office/drawing/2014/main" id="{78D72C9C-7456-3625-3938-1512EEF6CAD0}"/>
+              </a:ext>
+            </a:extLst>
+          </p:cNvPr>
+          <p:cNvSpPr/>
+          <p:nvPr/>
+        </p:nvSpPr>
+        <p:spPr>
+          <a:xfrm>
+            <a:off x="1701702" y="5431536"/>
+            <a:ext cx="1737360" cy="246888"/>
+          </a:xfrm>
+          <a:prstGeom prst="roundRect">
+            <a:avLst>
+              <a:gd name="adj" fmla="val 11111"/>
+            </a:avLst>
+          </a:prstGeom>
+          <a:solidFill>
+            <a:srgbClr val="FFFFFF"/>
+          </a:solidFill>
+          <a:ln w="10160">
+            <a:solidFill>
+              <a:srgbClr val="C5CDD5"/>
+            </a:solidFill>
+            <a:prstDash val="solid"/>
+          </a:ln>
+        </p:spPr>
+        <p:txBody>
+          <a:bodyPr/>
+          <a:lstStyle/>
+          <a:p>
+            <a:endParaRPr lang="en-US"/>
+          </a:p>
+        </p:txBody>
+      </p:sp>
+      <p:sp>
+        <p:nvSpPr>
+          <p:cNvPr id="40" name="Text 37">
+            <a:extLst>
+              <a:ext uri="{FF2B5EF4-FFF2-40B4-BE49-F238E27FC236}">
+                <a16:creationId xmlns:a16="http://schemas.microsoft.com/office/drawing/2014/main" id="{02F6AED4-95B0-00D5-0DA4-4D6C6BE7E4C6}"/>
+              </a:ext>
+            </a:extLst>
+          </p:cNvPr>
+          <p:cNvSpPr/>
+          <p:nvPr/>
+        </p:nvSpPr>
+        <p:spPr>
+          <a:xfrm>
+            <a:off x="1774854" y="5477256"/>
+            <a:ext cx="1600200" cy="128016"/>
+          </a:xfrm>
+          <a:prstGeom prst="rect">
+            <a:avLst/>
+          </a:prstGeom>
+          <a:noFill/>
+          <a:ln/>
+        </p:spPr>
+        <p:txBody>
+          <a:bodyPr wrap="square" lIns="0" tIns="0" rIns="0" bIns="0" rtlCol="0" anchor="ctr"/>
+          <a:lstStyle/>
+          <a:p>
+            <a:pPr marL="0" indent="0">
+              <a:buNone/>
+            </a:pPr>
+            <a:r>
+              <a:rPr lang="en-US" sz="800" dirty="0">
+                <a:solidFill>
+                  <a:srgbClr val="111111"/>
+                </a:solidFill>
+              </a:rPr>
+              <a:t>••••••••</a:t>
+            </a:r>
+            <a:endParaRPr lang="en-US" sz="800" dirty="0"/>
+          </a:p>
+        </p:txBody>
+      </p:sp>
+      <p:sp>
+        <p:nvSpPr>
+          <p:cNvPr id="41" name="Shape 38">
+            <a:extLst>
+              <a:ext uri="{FF2B5EF4-FFF2-40B4-BE49-F238E27FC236}">
+                <a16:creationId xmlns:a16="http://schemas.microsoft.com/office/drawing/2014/main" id="{DA8F3F1E-7BF2-2D35-FEF0-4CFD5475176C}"/>
+              </a:ext>
+            </a:extLst>
+          </p:cNvPr>
+          <p:cNvSpPr/>
+          <p:nvPr/>
+        </p:nvSpPr>
+        <p:spPr>
+          <a:xfrm>
+            <a:off x="1610262" y="5815584"/>
+            <a:ext cx="1143000" cy="320040"/>
+          </a:xfrm>
+          <a:prstGeom prst="roundRect">
+            <a:avLst>
+              <a:gd name="adj" fmla="val 17143"/>
+            </a:avLst>
+          </a:prstGeom>
+          <a:solidFill>
+            <a:srgbClr val="0E76D8"/>
+          </a:solidFill>
+          <a:ln w="10160">
+            <a:solidFill>
+              <a:srgbClr val="0560B7"/>
+            </a:solidFill>
+            <a:prstDash val="solid"/>
+          </a:ln>
+        </p:spPr>
+        <p:txBody>
+          <a:bodyPr/>
+          <a:lstStyle/>
+          <a:p>
+            <a:endParaRPr lang="en-US"/>
+          </a:p>
+        </p:txBody>
+      </p:sp>
+      <p:sp>
+        <p:nvSpPr>
+          <p:cNvPr id="42" name="Text 39">
+            <a:extLst>
+              <a:ext uri="{FF2B5EF4-FFF2-40B4-BE49-F238E27FC236}">
+                <a16:creationId xmlns:a16="http://schemas.microsoft.com/office/drawing/2014/main" id="{ABF3CF85-8559-39A0-471F-75232EDBDE17}"/>
+              </a:ext>
+            </a:extLst>
+          </p:cNvPr>
+          <p:cNvSpPr/>
+          <p:nvPr/>
+        </p:nvSpPr>
+        <p:spPr>
+          <a:xfrm>
+            <a:off x="1610262" y="5897880"/>
+            <a:ext cx="1143000" cy="128016"/>
+          </a:xfrm>
+          <a:prstGeom prst="rect">
+            <a:avLst/>
+          </a:prstGeom>
+          <a:noFill/>
+          <a:ln/>
+        </p:spPr>
+        <p:txBody>
+          <a:bodyPr wrap="square" lIns="0" tIns="0" rIns="0" bIns="0" rtlCol="0" anchor="ctr"/>
+          <a:lstStyle/>
+          <a:p>
+            <a:pPr marL="0" indent="0" algn="ctr">
+              <a:buNone/>
+            </a:pPr>
+            <a:r>
+              <a:rPr lang="en-US" sz="940" b="1" dirty="0">
+                <a:solidFill>
+                  <a:srgbClr val="FFFFFF"/>
+                </a:solidFill>
+              </a:rPr>
+              <a:t>Sign In</a:t>
+            </a:r>
+            <a:endParaRPr lang="en-US" sz="940" dirty="0"/>
+          </a:p>
+        </p:txBody>
+      </p:sp>
+      <p:sp>
+        <p:nvSpPr>
+          <p:cNvPr id="43" name="Shape 40">
+            <a:extLst>
+              <a:ext uri="{FF2B5EF4-FFF2-40B4-BE49-F238E27FC236}">
+                <a16:creationId xmlns:a16="http://schemas.microsoft.com/office/drawing/2014/main" id="{5AF86C96-F9BC-9977-8C91-C7C9741C58FE}"/>
+              </a:ext>
+            </a:extLst>
+          </p:cNvPr>
+          <p:cNvSpPr/>
+          <p:nvPr/>
+        </p:nvSpPr>
+        <p:spPr>
+          <a:xfrm>
+            <a:off x="6824529" y="4805199"/>
+            <a:ext cx="2084832" cy="1417320"/>
+          </a:xfrm>
+          <a:prstGeom prst="roundRect">
+            <a:avLst>
+              <a:gd name="adj" fmla="val 5161"/>
+            </a:avLst>
+          </a:prstGeom>
+          <a:solidFill>
+            <a:srgbClr val="FFF0F7"/>
+          </a:solidFill>
+          <a:ln w="17780">
+            <a:solidFill>
+              <a:srgbClr val="E61E73"/>
+            </a:solidFill>
+            <a:prstDash val="solid"/>
+          </a:ln>
+          <a:effectLst>
+            <a:outerShdw blurRad="19050" dist="7620" dir="2700000" algn="bl" rotWithShape="0">
+              <a:srgbClr val="000000">
+                <a:alpha val="10000"/>
+              </a:srgbClr>
+            </a:outerShdw>
+          </a:effectLst>
+        </p:spPr>
+        <p:txBody>
+          <a:bodyPr/>
+          <a:lstStyle/>
+          <a:p>
+            <a:endParaRPr lang="en-US"/>
+          </a:p>
+        </p:txBody>
+      </p:sp>
+      <p:sp>
+        <p:nvSpPr>
+          <p:cNvPr id="44" name="Text 42">
+            <a:extLst>
+              <a:ext uri="{FF2B5EF4-FFF2-40B4-BE49-F238E27FC236}">
+                <a16:creationId xmlns:a16="http://schemas.microsoft.com/office/drawing/2014/main" id="{63A18DEC-30EE-2542-F96A-C06E744BA087}"/>
+              </a:ext>
+            </a:extLst>
+          </p:cNvPr>
+          <p:cNvSpPr/>
+          <p:nvPr/>
+        </p:nvSpPr>
+        <p:spPr>
+          <a:xfrm>
+            <a:off x="7400601" y="4887495"/>
+            <a:ext cx="1399032" cy="228600"/>
+          </a:xfrm>
+          <a:prstGeom prst="rect">
+            <a:avLst/>
+          </a:prstGeom>
+          <a:noFill/>
+          <a:ln/>
+        </p:spPr>
+        <p:txBody>
+          <a:bodyPr wrap="square" lIns="127" tIns="127" rIns="127" bIns="127" rtlCol="0" anchor="ctr">
+            <a:normAutofit lnSpcReduction="10000"/>
+          </a:bodyPr>
+          <a:lstStyle/>
+          <a:p>
+            <a:pPr marL="0" indent="0">
+              <a:buNone/>
+            </a:pPr>
+            <a:r>
+              <a:rPr lang="en-US" sz="1600" b="1" dirty="0">
+                <a:solidFill>
+                  <a:srgbClr val="E61E73"/>
+                </a:solidFill>
+              </a:rPr>
+              <a:t>Login.css</a:t>
+            </a:r>
+            <a:endParaRPr lang="en-US" sz="1600" dirty="0"/>
+          </a:p>
+        </p:txBody>
+      </p:sp>
+      <p:sp>
+        <p:nvSpPr>
+          <p:cNvPr id="45" name="Text 43">
+            <a:extLst>
+              <a:ext uri="{FF2B5EF4-FFF2-40B4-BE49-F238E27FC236}">
+                <a16:creationId xmlns:a16="http://schemas.microsoft.com/office/drawing/2014/main" id="{CFBA937E-522D-2B35-82E2-777674DA6083}"/>
+              </a:ext>
+            </a:extLst>
+          </p:cNvPr>
+          <p:cNvSpPr/>
+          <p:nvPr/>
+        </p:nvSpPr>
+        <p:spPr>
+          <a:xfrm>
+            <a:off x="7400601" y="5135418"/>
+            <a:ext cx="1399032" cy="164592"/>
+          </a:xfrm>
+          <a:prstGeom prst="rect">
+            <a:avLst/>
+          </a:prstGeom>
+          <a:noFill/>
+          <a:ln/>
+        </p:spPr>
+        <p:txBody>
+          <a:bodyPr wrap="square" lIns="127" tIns="127" rIns="127" bIns="127" rtlCol="0" anchor="ctr">
+            <a:normAutofit/>
+          </a:bodyPr>
+          <a:lstStyle/>
+          <a:p>
+            <a:pPr marL="0" indent="0">
+              <a:buNone/>
+            </a:pPr>
+            <a:r>
+              <a:rPr lang="en-US" sz="880" dirty="0">
+                <a:solidFill>
+                  <a:srgbClr val="E61E73"/>
+                </a:solidFill>
+              </a:rPr>
+              <a:t>(Styles / Appearance)</a:t>
+            </a:r>
+            <a:endParaRPr lang="en-US" sz="880" dirty="0"/>
+          </a:p>
+        </p:txBody>
+      </p:sp>
+      <p:sp>
+        <p:nvSpPr>
+          <p:cNvPr id="46" name="Shape 44">
+            <a:extLst>
+              <a:ext uri="{FF2B5EF4-FFF2-40B4-BE49-F238E27FC236}">
+                <a16:creationId xmlns:a16="http://schemas.microsoft.com/office/drawing/2014/main" id="{EC8F95DD-E5AA-0135-535A-ADADC9EFA05D}"/>
+              </a:ext>
+            </a:extLst>
+          </p:cNvPr>
+          <p:cNvSpPr/>
+          <p:nvPr/>
+        </p:nvSpPr>
+        <p:spPr>
+          <a:xfrm>
+            <a:off x="6895381" y="5335550"/>
+            <a:ext cx="1922540" cy="672057"/>
+          </a:xfrm>
+          <a:prstGeom prst="roundRect">
+            <a:avLst>
+              <a:gd name="adj" fmla="val 7692"/>
+            </a:avLst>
+          </a:prstGeom>
+          <a:solidFill>
+            <a:srgbClr val="FFFFFF">
+              <a:alpha val="96000"/>
+            </a:srgbClr>
+          </a:solidFill>
+          <a:ln w="8890">
+            <a:solidFill>
+              <a:srgbClr val="D9E2EA"/>
+            </a:solidFill>
+            <a:prstDash val="solid"/>
+          </a:ln>
+        </p:spPr>
+        <p:txBody>
+          <a:bodyPr/>
+          <a:lstStyle/>
+          <a:p>
+            <a:endParaRPr lang="en-US"/>
+          </a:p>
+        </p:txBody>
+      </p:sp>
+      <p:sp>
+        <p:nvSpPr>
+          <p:cNvPr id="47" name="Text 45">
+            <a:extLst>
+              <a:ext uri="{FF2B5EF4-FFF2-40B4-BE49-F238E27FC236}">
+                <a16:creationId xmlns:a16="http://schemas.microsoft.com/office/drawing/2014/main" id="{88A4250D-0A4F-3098-5C9B-489C12A4C30C}"/>
+              </a:ext>
+            </a:extLst>
+          </p:cNvPr>
+          <p:cNvSpPr/>
+          <p:nvPr/>
+        </p:nvSpPr>
+        <p:spPr>
+          <a:xfrm>
+            <a:off x="6925113" y="5359446"/>
+            <a:ext cx="1956816" cy="529317"/>
+          </a:xfrm>
+          <a:prstGeom prst="rect">
+            <a:avLst/>
+          </a:prstGeom>
+          <a:noFill/>
+          <a:ln/>
+        </p:spPr>
+        <p:txBody>
+          <a:bodyPr wrap="square" lIns="0" tIns="0" rIns="0" bIns="0" rtlCol="0" anchor="t">
+            <a:noAutofit/>
+          </a:bodyPr>
+          <a:lstStyle/>
+          <a:p>
+            <a:pPr marL="0" indent="0">
+              <a:buNone/>
+            </a:pPr>
+            <a:r>
+              <a:rPr lang="en-US" sz="700" dirty="0">
+                <a:solidFill>
+                  <a:srgbClr val="111111"/>
+                </a:solidFill>
+                <a:latin typeface="Courier New" pitchFamily="34" charset="0"/>
+                <a:ea typeface="Courier New" pitchFamily="34" charset="-122"/>
+                <a:cs typeface="Courier New" pitchFamily="34" charset="-120"/>
+              </a:rPr>
+              <a:t>.primary {</a:t>
+            </a:r>
+            <a:endParaRPr lang="en-US" sz="700" dirty="0"/>
+          </a:p>
+          <a:p>
+            <a:pPr marL="0" indent="0">
+              <a:buNone/>
+            </a:pPr>
+            <a:r>
+              <a:rPr lang="en-US" sz="700" dirty="0">
+                <a:solidFill>
+                  <a:srgbClr val="111111"/>
+                </a:solidFill>
+                <a:latin typeface="Courier New" pitchFamily="34" charset="0"/>
+                <a:ea typeface="Courier New" pitchFamily="34" charset="-122"/>
+                <a:cs typeface="Courier New" pitchFamily="34" charset="-120"/>
+              </a:rPr>
+              <a:t>  -fx-font-weight: bold;</a:t>
+            </a:r>
+            <a:endParaRPr lang="en-US" sz="700" dirty="0"/>
+          </a:p>
+          <a:p>
+            <a:pPr marL="0" indent="0">
+              <a:buNone/>
+            </a:pPr>
+            <a:r>
+              <a:rPr lang="en-US" sz="700" dirty="0">
+                <a:solidFill>
+                  <a:srgbClr val="111111"/>
+                </a:solidFill>
+                <a:latin typeface="Courier New" pitchFamily="34" charset="0"/>
+                <a:ea typeface="Courier New" pitchFamily="34" charset="-122"/>
+                <a:cs typeface="Courier New" pitchFamily="34" charset="-120"/>
+              </a:rPr>
+              <a:t>  -</a:t>
+            </a:r>
+            <a:r>
+              <a:rPr lang="en-US" sz="700" dirty="0" err="1">
+                <a:solidFill>
+                  <a:srgbClr val="111111"/>
+                </a:solidFill>
+                <a:latin typeface="Courier New" pitchFamily="34" charset="0"/>
+                <a:ea typeface="Courier New" pitchFamily="34" charset="-122"/>
+                <a:cs typeface="Courier New" pitchFamily="34" charset="-120"/>
+              </a:rPr>
+              <a:t>fx</a:t>
+            </a:r>
+            <a:r>
+              <a:rPr lang="en-US" sz="700" dirty="0">
+                <a:solidFill>
+                  <a:srgbClr val="111111"/>
+                </a:solidFill>
+                <a:latin typeface="Courier New" pitchFamily="34" charset="0"/>
+                <a:ea typeface="Courier New" pitchFamily="34" charset="-122"/>
+                <a:cs typeface="Courier New" pitchFamily="34" charset="-120"/>
+              </a:rPr>
+              <a:t>-background-color: #0078D7;</a:t>
+            </a:r>
+            <a:endParaRPr lang="en-US" sz="700" dirty="0"/>
+          </a:p>
+          <a:p>
+            <a:pPr marL="0" indent="0">
+              <a:buNone/>
+            </a:pPr>
+            <a:r>
+              <a:rPr lang="en-US" sz="700" dirty="0">
+                <a:solidFill>
+                  <a:srgbClr val="111111"/>
+                </a:solidFill>
+                <a:latin typeface="Courier New" pitchFamily="34" charset="0"/>
+                <a:ea typeface="Courier New" pitchFamily="34" charset="-122"/>
+                <a:cs typeface="Courier New" pitchFamily="34" charset="-120"/>
+              </a:rPr>
+              <a:t>  -fx-text-fill: white;</a:t>
+            </a:r>
+            <a:endParaRPr lang="en-US" sz="700" dirty="0"/>
+          </a:p>
+          <a:p>
+            <a:pPr marL="0" indent="0">
+              <a:buNone/>
+            </a:pPr>
+            <a:r>
+              <a:rPr lang="en-US" sz="700" dirty="0">
+                <a:solidFill>
+                  <a:srgbClr val="111111"/>
+                </a:solidFill>
+                <a:latin typeface="Courier New" pitchFamily="34" charset="0"/>
+                <a:ea typeface="Courier New" pitchFamily="34" charset="-122"/>
+                <a:cs typeface="Courier New" pitchFamily="34" charset="-120"/>
+              </a:rPr>
+              <a:t>  -fx-background-radius: 5;</a:t>
+            </a:r>
+            <a:endParaRPr lang="en-US" sz="700" dirty="0"/>
+          </a:p>
+          <a:p>
+            <a:pPr marL="0" indent="0">
+              <a:buNone/>
+            </a:pPr>
+            <a:r>
+              <a:rPr lang="en-US" sz="700" dirty="0">
+                <a:solidFill>
+                  <a:srgbClr val="111111"/>
+                </a:solidFill>
+                <a:latin typeface="Courier New" pitchFamily="34" charset="0"/>
+                <a:ea typeface="Courier New" pitchFamily="34" charset="-122"/>
+                <a:cs typeface="Courier New" pitchFamily="34" charset="-120"/>
+              </a:rPr>
+              <a:t>}</a:t>
+            </a:r>
+            <a:endParaRPr lang="en-US" sz="700" dirty="0"/>
+          </a:p>
+        </p:txBody>
+      </p:sp>
+      <p:sp>
+        <p:nvSpPr>
+          <p:cNvPr id="48" name="Text 46">
+            <a:extLst>
+              <a:ext uri="{FF2B5EF4-FFF2-40B4-BE49-F238E27FC236}">
+                <a16:creationId xmlns:a16="http://schemas.microsoft.com/office/drawing/2014/main" id="{DAE24EBA-4375-3994-A6FC-AB39D8A10C8F}"/>
+              </a:ext>
+            </a:extLst>
+          </p:cNvPr>
+          <p:cNvSpPr/>
+          <p:nvPr/>
+        </p:nvSpPr>
+        <p:spPr>
+          <a:xfrm>
+            <a:off x="7053129" y="5987421"/>
+            <a:ext cx="1746504" cy="219456"/>
+          </a:xfrm>
+          <a:prstGeom prst="rect">
+            <a:avLst/>
+          </a:prstGeom>
+          <a:noFill/>
+          <a:ln/>
+        </p:spPr>
+        <p:txBody>
+          <a:bodyPr wrap="square" lIns="127" tIns="127" rIns="127" bIns="127" rtlCol="0" anchor="ctr">
+            <a:normAutofit/>
+          </a:bodyPr>
+          <a:lstStyle/>
+          <a:p>
+            <a:pPr marL="0" indent="0" algn="ctr">
+              <a:buNone/>
+            </a:pPr>
+            <a:r>
+              <a:rPr lang="en-US" sz="920" dirty="0">
+                <a:solidFill>
+                  <a:srgbClr val="E61E73"/>
+                </a:solidFill>
+              </a:rPr>
+              <a:t>Defines the appearance (styles)</a:t>
+            </a:r>
+            <a:endParaRPr lang="en-US" sz="920" dirty="0"/>
+          </a:p>
+        </p:txBody>
+      </p:sp>
+      <p:sp>
+        <p:nvSpPr>
+          <p:cNvPr id="49" name="Shape 47">
+            <a:extLst>
+              <a:ext uri="{FF2B5EF4-FFF2-40B4-BE49-F238E27FC236}">
+                <a16:creationId xmlns:a16="http://schemas.microsoft.com/office/drawing/2014/main" id="{CCED7FDD-CB20-0C63-3030-9A6A13BE563D}"/>
+              </a:ext>
+            </a:extLst>
+          </p:cNvPr>
+          <p:cNvSpPr/>
+          <p:nvPr/>
+        </p:nvSpPr>
+        <p:spPr>
+          <a:xfrm flipH="1" flipV="1">
+            <a:off x="3108960" y="1188720"/>
+            <a:ext cx="3520440" cy="18288"/>
+          </a:xfrm>
+          <a:prstGeom prst="line">
+            <a:avLst/>
+          </a:prstGeom>
+          <a:noFill/>
+          <a:ln w="33020">
+            <a:solidFill>
+              <a:srgbClr val="0E76D8"/>
+            </a:solidFill>
+            <a:prstDash val="solid"/>
+            <a:headEnd type="none"/>
+            <a:tailEnd type="triangle"/>
+          </a:ln>
+        </p:spPr>
+        <p:txBody>
+          <a:bodyPr/>
+          <a:lstStyle/>
+          <a:p>
+            <a:endParaRPr lang="en-US"/>
+          </a:p>
+        </p:txBody>
+      </p:sp>
+      <p:sp>
+        <p:nvSpPr>
+          <p:cNvPr id="50" name="Text 48">
+            <a:extLst>
+              <a:ext uri="{FF2B5EF4-FFF2-40B4-BE49-F238E27FC236}">
+                <a16:creationId xmlns:a16="http://schemas.microsoft.com/office/drawing/2014/main" id="{322C5C91-32BC-F266-7C11-9CF8D37B2290}"/>
+              </a:ext>
+            </a:extLst>
+          </p:cNvPr>
+          <p:cNvSpPr/>
+          <p:nvPr/>
+        </p:nvSpPr>
+        <p:spPr>
+          <a:xfrm>
+            <a:off x="3886200" y="932688"/>
+            <a:ext cx="2148840" cy="228600"/>
+          </a:xfrm>
+          <a:prstGeom prst="rect">
+            <a:avLst/>
+          </a:prstGeom>
+          <a:noFill/>
+          <a:ln/>
+        </p:spPr>
+        <p:txBody>
+          <a:bodyPr wrap="square" lIns="127" tIns="127" rIns="127" bIns="127" rtlCol="0" anchor="ctr">
+            <a:normAutofit/>
+          </a:bodyPr>
+          <a:lstStyle/>
+          <a:p>
+            <a:pPr marL="0" indent="0" algn="ctr">
+              <a:buNone/>
+            </a:pPr>
+            <a:r>
+              <a:rPr lang="en-US" sz="1250" b="1" dirty="0">
+                <a:solidFill>
+                  <a:srgbClr val="0E76D8"/>
+                </a:solidFill>
+                <a:latin typeface="Arial" pitchFamily="34" charset="0"/>
+                <a:ea typeface="Arial" pitchFamily="34" charset="-122"/>
+                <a:cs typeface="Arial" pitchFamily="34" charset="-120"/>
+              </a:rPr>
+              <a:t>loaded by </a:t>
+            </a:r>
+            <a:r>
+              <a:rPr lang="en-US" sz="1200" b="1" dirty="0">
+                <a:solidFill>
+                  <a:srgbClr val="0E76D8"/>
+                </a:solidFill>
+                <a:latin typeface="Arial" pitchFamily="34" charset="0"/>
+                <a:ea typeface="Arial" pitchFamily="34" charset="-122"/>
+                <a:cs typeface="Arial" pitchFamily="34" charset="-120"/>
+              </a:rPr>
+              <a:t>MainApp</a:t>
+            </a:r>
+            <a:endParaRPr lang="en-US" sz="1200" dirty="0"/>
+          </a:p>
+        </p:txBody>
+      </p:sp>
+      <p:sp>
+        <p:nvSpPr>
+          <p:cNvPr id="51" name="Text 49">
+            <a:extLst>
+              <a:ext uri="{FF2B5EF4-FFF2-40B4-BE49-F238E27FC236}">
+                <a16:creationId xmlns:a16="http://schemas.microsoft.com/office/drawing/2014/main" id="{957F0BE1-57E9-0379-A5DA-C9930BF34182}"/>
+              </a:ext>
+            </a:extLst>
+          </p:cNvPr>
+          <p:cNvSpPr/>
+          <p:nvPr/>
+        </p:nvSpPr>
+        <p:spPr>
+          <a:xfrm>
+            <a:off x="4023360" y="1232283"/>
+            <a:ext cx="1874520" cy="164592"/>
+          </a:xfrm>
+          <a:prstGeom prst="rect">
+            <a:avLst/>
+          </a:prstGeom>
+          <a:noFill/>
+          <a:ln/>
+        </p:spPr>
+        <p:txBody>
+          <a:bodyPr wrap="square" lIns="127" tIns="127" rIns="127" bIns="127" rtlCol="0" anchor="ctr">
+            <a:normAutofit/>
+          </a:bodyPr>
+          <a:lstStyle/>
+          <a:p>
+            <a:pPr marL="0" indent="0" algn="ctr">
+              <a:buNone/>
+            </a:pPr>
+            <a:r>
+              <a:rPr lang="en-US" sz="1000" dirty="0">
+                <a:solidFill>
+                  <a:srgbClr val="0E2D63"/>
+                </a:solidFill>
+                <a:latin typeface="Arial" pitchFamily="34" charset="0"/>
+                <a:ea typeface="Arial" pitchFamily="34" charset="-122"/>
+                <a:cs typeface="Arial" pitchFamily="34" charset="-120"/>
+              </a:rPr>
+              <a:t>MainApp loads the FXML</a:t>
+            </a:r>
+            <a:endParaRPr lang="en-US" sz="1000" dirty="0"/>
+          </a:p>
+        </p:txBody>
+      </p:sp>
+      <p:sp>
+        <p:nvSpPr>
+          <p:cNvPr id="52" name="Shape 50">
+            <a:extLst>
+              <a:ext uri="{FF2B5EF4-FFF2-40B4-BE49-F238E27FC236}">
+                <a16:creationId xmlns:a16="http://schemas.microsoft.com/office/drawing/2014/main" id="{F2812693-B9CE-328A-1776-E1E36DA3C2AC}"/>
+              </a:ext>
+            </a:extLst>
+          </p:cNvPr>
+          <p:cNvSpPr/>
+          <p:nvPr/>
+        </p:nvSpPr>
+        <p:spPr>
+          <a:xfrm>
+            <a:off x="1664208" y="3063240"/>
+            <a:ext cx="0" cy="1234440"/>
+          </a:xfrm>
+          <a:prstGeom prst="line">
+            <a:avLst/>
+          </a:prstGeom>
+          <a:noFill/>
+          <a:ln w="35560">
+            <a:solidFill>
+              <a:srgbClr val="0E76D8"/>
+            </a:solidFill>
+            <a:prstDash val="solid"/>
+            <a:headEnd type="none"/>
+            <a:tailEnd type="triangle"/>
+          </a:ln>
+        </p:spPr>
+        <p:txBody>
+          <a:bodyPr/>
+          <a:lstStyle/>
+          <a:p>
+            <a:endParaRPr lang="en-US"/>
+          </a:p>
+        </p:txBody>
+      </p:sp>
+      <p:sp>
+        <p:nvSpPr>
+          <p:cNvPr id="53" name="Text 51">
+            <a:extLst>
+              <a:ext uri="{FF2B5EF4-FFF2-40B4-BE49-F238E27FC236}">
+                <a16:creationId xmlns:a16="http://schemas.microsoft.com/office/drawing/2014/main" id="{3D9C2D4D-C5B4-5C2B-A778-DB6C772121A4}"/>
+              </a:ext>
+            </a:extLst>
+          </p:cNvPr>
+          <p:cNvSpPr/>
+          <p:nvPr/>
+        </p:nvSpPr>
+        <p:spPr>
+          <a:xfrm>
+            <a:off x="348390" y="3364992"/>
+            <a:ext cx="1371600" cy="256032"/>
+          </a:xfrm>
+          <a:prstGeom prst="rect">
+            <a:avLst/>
+          </a:prstGeom>
+          <a:noFill/>
+          <a:ln/>
+        </p:spPr>
+        <p:txBody>
+          <a:bodyPr wrap="square" lIns="127" tIns="127" rIns="127" bIns="127" rtlCol="0" anchor="ctr">
+            <a:noAutofit/>
+          </a:bodyPr>
+          <a:lstStyle/>
+          <a:p>
+            <a:pPr marL="0" indent="0" algn="ctr">
+              <a:buNone/>
+            </a:pPr>
+            <a:r>
+              <a:rPr lang="en-US" sz="1200" b="1" dirty="0">
+                <a:solidFill>
+                  <a:srgbClr val="0E76D8"/>
+                </a:solidFill>
+                <a:latin typeface="Arial" pitchFamily="34" charset="0"/>
+                <a:ea typeface="Arial" pitchFamily="34" charset="-122"/>
+                <a:cs typeface="Arial" pitchFamily="34" charset="-120"/>
+              </a:rPr>
+              <a:t>Sets Scene and </a:t>
+            </a:r>
+          </a:p>
+          <a:p>
+            <a:pPr marL="0" indent="0" algn="ctr">
+              <a:buNone/>
+            </a:pPr>
+            <a:r>
+              <a:rPr lang="en-US" sz="1200" b="1" dirty="0">
+                <a:solidFill>
+                  <a:srgbClr val="0E76D8"/>
+                </a:solidFill>
+                <a:latin typeface="Arial" pitchFamily="34" charset="0"/>
+                <a:ea typeface="Arial" pitchFamily="34" charset="-122"/>
+                <a:cs typeface="Arial" pitchFamily="34" charset="-120"/>
+              </a:rPr>
+              <a:t>shows stage</a:t>
+            </a:r>
+            <a:endParaRPr lang="en-US" sz="1200" dirty="0"/>
+          </a:p>
+        </p:txBody>
+      </p:sp>
+      <p:sp>
+        <p:nvSpPr>
+          <p:cNvPr id="54" name="Text 52">
+            <a:extLst>
+              <a:ext uri="{FF2B5EF4-FFF2-40B4-BE49-F238E27FC236}">
+                <a16:creationId xmlns:a16="http://schemas.microsoft.com/office/drawing/2014/main" id="{861AB8D1-D7A0-2486-8BCB-4903B11331A6}"/>
+              </a:ext>
+            </a:extLst>
+          </p:cNvPr>
+          <p:cNvSpPr/>
+          <p:nvPr/>
+        </p:nvSpPr>
+        <p:spPr>
+          <a:xfrm>
+            <a:off x="338328" y="3717036"/>
+            <a:ext cx="1325877" cy="320040"/>
+          </a:xfrm>
+          <a:prstGeom prst="rect">
+            <a:avLst/>
+          </a:prstGeom>
+          <a:noFill/>
+          <a:ln/>
+        </p:spPr>
+        <p:txBody>
+          <a:bodyPr wrap="square" lIns="127" tIns="127" rIns="127" bIns="127" rtlCol="0" anchor="ctr">
+            <a:noAutofit/>
+          </a:bodyPr>
+          <a:lstStyle/>
+          <a:p>
+            <a:pPr marL="0" indent="0" algn="ctr">
+              <a:buNone/>
+            </a:pPr>
+            <a:r>
+              <a:rPr lang="en-US" sz="1000" dirty="0">
+                <a:solidFill>
+                  <a:srgbClr val="0E2D63"/>
+                </a:solidFill>
+                <a:latin typeface="Arial" pitchFamily="34" charset="0"/>
+                <a:ea typeface="Arial" pitchFamily="34" charset="-122"/>
+                <a:cs typeface="Arial" pitchFamily="34" charset="-120"/>
+              </a:rPr>
+              <a:t>MainApp creates</a:t>
+            </a:r>
+            <a:endParaRPr lang="en-US" sz="1000" dirty="0"/>
+          </a:p>
+          <a:p>
+            <a:pPr marL="0" indent="0" algn="ctr">
+              <a:buNone/>
+            </a:pPr>
+            <a:r>
+              <a:rPr lang="en-US" sz="1000" dirty="0">
+                <a:solidFill>
+                  <a:srgbClr val="0E2D63"/>
+                </a:solidFill>
+                <a:latin typeface="Arial" pitchFamily="34" charset="0"/>
+                <a:ea typeface="Arial" pitchFamily="34" charset="-122"/>
+                <a:cs typeface="Arial" pitchFamily="34" charset="-120"/>
+              </a:rPr>
+              <a:t>and shows the window</a:t>
+            </a:r>
+            <a:endParaRPr lang="en-US" sz="1000" dirty="0"/>
+          </a:p>
+        </p:txBody>
+      </p:sp>
+      <p:sp>
+        <p:nvSpPr>
+          <p:cNvPr id="55" name="Shape 53">
+            <a:extLst>
+              <a:ext uri="{FF2B5EF4-FFF2-40B4-BE49-F238E27FC236}">
+                <a16:creationId xmlns:a16="http://schemas.microsoft.com/office/drawing/2014/main" id="{FE0F6479-5B5F-2DE3-C360-28DA17DD1F61}"/>
+              </a:ext>
+            </a:extLst>
+          </p:cNvPr>
+          <p:cNvSpPr/>
+          <p:nvPr/>
+        </p:nvSpPr>
+        <p:spPr>
+          <a:xfrm flipH="1">
+            <a:off x="5285230" y="2212848"/>
+            <a:ext cx="1344170" cy="0"/>
+          </a:xfrm>
+          <a:prstGeom prst="line">
+            <a:avLst/>
+          </a:prstGeom>
+          <a:noFill/>
+          <a:ln w="33020">
+            <a:solidFill>
+              <a:srgbClr val="12984B"/>
+            </a:solidFill>
+            <a:prstDash val="solid"/>
+            <a:headEnd type="none"/>
+            <a:tailEnd type="triangle"/>
+          </a:ln>
+        </p:spPr>
+        <p:txBody>
+          <a:bodyPr/>
+          <a:lstStyle/>
+          <a:p>
+            <a:endParaRPr lang="en-US"/>
+          </a:p>
+        </p:txBody>
+      </p:sp>
+      <p:sp>
+        <p:nvSpPr>
+          <p:cNvPr id="56" name="Text 54">
+            <a:extLst>
+              <a:ext uri="{FF2B5EF4-FFF2-40B4-BE49-F238E27FC236}">
+                <a16:creationId xmlns:a16="http://schemas.microsoft.com/office/drawing/2014/main" id="{010D8255-AC1A-FE25-0295-F06566ADE516}"/>
+              </a:ext>
+            </a:extLst>
+          </p:cNvPr>
+          <p:cNvSpPr/>
+          <p:nvPr/>
+        </p:nvSpPr>
+        <p:spPr>
+          <a:xfrm>
+            <a:off x="5218177" y="1847088"/>
+            <a:ext cx="1453891" cy="310897"/>
+          </a:xfrm>
+          <a:prstGeom prst="rect">
+            <a:avLst/>
+          </a:prstGeom>
+          <a:noFill/>
+          <a:ln/>
+        </p:spPr>
+        <p:txBody>
+          <a:bodyPr wrap="square" lIns="127" tIns="127" rIns="127" bIns="127" rtlCol="0" anchor="ctr">
+            <a:noAutofit/>
+          </a:bodyPr>
+          <a:lstStyle/>
+          <a:p>
+            <a:pPr marL="0" indent="0" algn="ctr">
+              <a:buNone/>
+            </a:pPr>
+            <a:r>
+              <a:rPr lang="en-US" sz="1200" b="1" dirty="0" err="1">
+                <a:solidFill>
+                  <a:srgbClr val="12984B"/>
+                </a:solidFill>
+                <a:latin typeface="Arial" pitchFamily="34" charset="0"/>
+                <a:ea typeface="Arial" pitchFamily="34" charset="-122"/>
+                <a:cs typeface="Arial" pitchFamily="34" charset="-120"/>
+              </a:rPr>
+              <a:t>fx:controller</a:t>
+            </a:r>
+            <a:r>
+              <a:rPr lang="en-US" sz="1200" b="1" dirty="0">
+                <a:solidFill>
+                  <a:srgbClr val="12984B"/>
+                </a:solidFill>
+                <a:latin typeface="Arial" pitchFamily="34" charset="0"/>
+                <a:ea typeface="Arial" pitchFamily="34" charset="-122"/>
+                <a:cs typeface="Arial" pitchFamily="34" charset="-120"/>
+              </a:rPr>
+              <a:t>, </a:t>
+            </a:r>
+            <a:r>
+              <a:rPr lang="en-US" sz="1200" b="1" dirty="0" err="1">
+                <a:solidFill>
+                  <a:srgbClr val="12984B"/>
+                </a:solidFill>
+                <a:latin typeface="Arial" pitchFamily="34" charset="0"/>
+                <a:ea typeface="Arial" pitchFamily="34" charset="-122"/>
+                <a:cs typeface="Arial" pitchFamily="34" charset="-120"/>
+              </a:rPr>
+              <a:t>fx:id</a:t>
+            </a:r>
+            <a:endParaRPr lang="en-US" sz="1200" b="1" dirty="0">
+              <a:solidFill>
+                <a:srgbClr val="12984B"/>
+              </a:solidFill>
+              <a:latin typeface="Arial" pitchFamily="34" charset="0"/>
+              <a:ea typeface="Arial" pitchFamily="34" charset="-122"/>
+              <a:cs typeface="Arial" pitchFamily="34" charset="-120"/>
+            </a:endParaRPr>
+          </a:p>
+          <a:p>
+            <a:pPr marL="0" indent="0" algn="ctr">
+              <a:buNone/>
+            </a:pPr>
+            <a:r>
+              <a:rPr lang="en-US" sz="1200" b="1" dirty="0">
+                <a:solidFill>
+                  <a:srgbClr val="12984B"/>
+                </a:solidFill>
+                <a:latin typeface="Arial" pitchFamily="34" charset="0"/>
+                <a:ea typeface="Arial" pitchFamily="34" charset="-122"/>
+                <a:cs typeface="Arial" pitchFamily="34" charset="-120"/>
+              </a:rPr>
+              <a:t> </a:t>
+            </a:r>
+            <a:r>
+              <a:rPr lang="en-US" sz="1200" b="1" dirty="0" err="1">
+                <a:solidFill>
+                  <a:srgbClr val="12984B"/>
+                </a:solidFill>
+                <a:latin typeface="Arial" pitchFamily="34" charset="0"/>
+                <a:ea typeface="Arial" pitchFamily="34" charset="-122"/>
+                <a:cs typeface="Arial" pitchFamily="34" charset="-120"/>
+              </a:rPr>
+              <a:t>onAcrtion</a:t>
+            </a:r>
+            <a:endParaRPr lang="en-US" sz="1200" dirty="0"/>
+          </a:p>
+        </p:txBody>
+      </p:sp>
+      <p:sp>
+        <p:nvSpPr>
+          <p:cNvPr id="57" name="Text 55">
+            <a:extLst>
+              <a:ext uri="{FF2B5EF4-FFF2-40B4-BE49-F238E27FC236}">
+                <a16:creationId xmlns:a16="http://schemas.microsoft.com/office/drawing/2014/main" id="{D5D0E6CF-26DD-4222-6497-8424EC7D96DE}"/>
+              </a:ext>
+            </a:extLst>
+          </p:cNvPr>
+          <p:cNvSpPr/>
+          <p:nvPr/>
+        </p:nvSpPr>
+        <p:spPr>
+          <a:xfrm>
+            <a:off x="5305646" y="2203704"/>
+            <a:ext cx="1307591" cy="502920"/>
+          </a:xfrm>
+          <a:prstGeom prst="rect">
+            <a:avLst/>
+          </a:prstGeom>
+          <a:noFill/>
+          <a:ln/>
+        </p:spPr>
+        <p:txBody>
+          <a:bodyPr wrap="square" lIns="127" tIns="127" rIns="127" bIns="127" rtlCol="0" anchor="ctr">
+            <a:normAutofit/>
+          </a:bodyPr>
+          <a:lstStyle/>
+          <a:p>
+            <a:pPr marL="0" indent="0" algn="ctr">
+              <a:buNone/>
+            </a:pPr>
+            <a:r>
+              <a:rPr lang="en-US" sz="1000" dirty="0">
+                <a:solidFill>
+                  <a:srgbClr val="0E2D63"/>
+                </a:solidFill>
+                <a:latin typeface="Arial" pitchFamily="34" charset="0"/>
+                <a:ea typeface="Arial" pitchFamily="34" charset="-122"/>
+                <a:cs typeface="Arial" pitchFamily="34" charset="-120"/>
+              </a:rPr>
+              <a:t>FXML specifies</a:t>
+            </a:r>
+            <a:endParaRPr lang="en-US" sz="1000" dirty="0"/>
+          </a:p>
+          <a:p>
+            <a:pPr marL="0" indent="0" algn="ctr">
+              <a:buNone/>
+            </a:pPr>
+            <a:r>
+              <a:rPr lang="en-US" sz="1000" dirty="0">
+                <a:solidFill>
+                  <a:srgbClr val="0E2D63"/>
+                </a:solidFill>
+                <a:latin typeface="Arial" pitchFamily="34" charset="0"/>
+                <a:ea typeface="Arial" pitchFamily="34" charset="-122"/>
+                <a:cs typeface="Arial" pitchFamily="34" charset="-120"/>
+              </a:rPr>
+              <a:t>which controller</a:t>
+            </a:r>
+            <a:r>
+              <a:rPr lang="en-US" sz="1000" dirty="0"/>
+              <a:t> </a:t>
+            </a:r>
+            <a:r>
+              <a:rPr lang="en-US" sz="1000" dirty="0">
+                <a:solidFill>
+                  <a:srgbClr val="0E2D63"/>
+                </a:solidFill>
+                <a:latin typeface="Arial" pitchFamily="34" charset="0"/>
+                <a:ea typeface="Arial" pitchFamily="34" charset="-122"/>
+                <a:cs typeface="Arial" pitchFamily="34" charset="-120"/>
+              </a:rPr>
+              <a:t>to use</a:t>
+            </a:r>
+            <a:endParaRPr lang="en-US" sz="1000" dirty="0"/>
+          </a:p>
+        </p:txBody>
+      </p:sp>
+      <p:sp>
+        <p:nvSpPr>
+          <p:cNvPr id="58" name="Shape 56">
+            <a:extLst>
+              <a:ext uri="{FF2B5EF4-FFF2-40B4-BE49-F238E27FC236}">
+                <a16:creationId xmlns:a16="http://schemas.microsoft.com/office/drawing/2014/main" id="{A492F135-85B6-1925-DC07-68E2C7D7DCD4}"/>
+              </a:ext>
+            </a:extLst>
+          </p:cNvPr>
+          <p:cNvSpPr/>
+          <p:nvPr/>
+        </p:nvSpPr>
+        <p:spPr>
+          <a:xfrm>
+            <a:off x="4187952" y="3785616"/>
+            <a:ext cx="0" cy="512064"/>
+          </a:xfrm>
+          <a:prstGeom prst="line">
+            <a:avLst/>
+          </a:prstGeom>
+          <a:noFill/>
+          <a:ln w="33020">
+            <a:solidFill>
+              <a:srgbClr val="F27616"/>
+            </a:solidFill>
+            <a:prstDash val="solid"/>
+            <a:headEnd type="none"/>
+            <a:tailEnd type="triangle"/>
+          </a:ln>
+        </p:spPr>
+        <p:txBody>
+          <a:bodyPr/>
+          <a:lstStyle/>
+          <a:p>
+            <a:endParaRPr lang="en-US"/>
+          </a:p>
+        </p:txBody>
+      </p:sp>
+      <p:sp>
+        <p:nvSpPr>
+          <p:cNvPr id="59" name="Text 57">
+            <a:extLst>
+              <a:ext uri="{FF2B5EF4-FFF2-40B4-BE49-F238E27FC236}">
+                <a16:creationId xmlns:a16="http://schemas.microsoft.com/office/drawing/2014/main" id="{04F52105-CDC0-0748-8974-E8BE7949E8DB}"/>
+              </a:ext>
+            </a:extLst>
+          </p:cNvPr>
+          <p:cNvSpPr/>
+          <p:nvPr/>
+        </p:nvSpPr>
+        <p:spPr>
+          <a:xfrm>
+            <a:off x="4223951" y="3886199"/>
+            <a:ext cx="1384365" cy="182880"/>
+          </a:xfrm>
+          <a:prstGeom prst="rect">
+            <a:avLst/>
+          </a:prstGeom>
+          <a:noFill/>
+          <a:ln/>
+        </p:spPr>
+        <p:txBody>
+          <a:bodyPr wrap="square" lIns="127" tIns="127" rIns="127" bIns="127" rtlCol="0" anchor="ctr">
+            <a:noAutofit/>
+          </a:bodyPr>
+          <a:lstStyle/>
+          <a:p>
+            <a:pPr marL="0" indent="0" algn="ctr">
+              <a:buNone/>
+            </a:pPr>
+            <a:r>
+              <a:rPr lang="en-US" sz="1200" b="1" dirty="0">
+                <a:solidFill>
+                  <a:srgbClr val="F27616"/>
+                </a:solidFill>
+                <a:latin typeface="Arial" pitchFamily="34" charset="0"/>
+                <a:ea typeface="Arial" pitchFamily="34" charset="-122"/>
+                <a:cs typeface="Arial" pitchFamily="34" charset="-120"/>
+              </a:rPr>
+              <a:t>handles behavior</a:t>
+            </a:r>
+            <a:endParaRPr lang="en-US" sz="1200" dirty="0"/>
+          </a:p>
+        </p:txBody>
+      </p:sp>
+      <p:sp>
+        <p:nvSpPr>
+          <p:cNvPr id="60" name="Text 58">
+            <a:extLst>
+              <a:ext uri="{FF2B5EF4-FFF2-40B4-BE49-F238E27FC236}">
+                <a16:creationId xmlns:a16="http://schemas.microsoft.com/office/drawing/2014/main" id="{9470C28E-7FF0-E399-8EEF-B2C958009609}"/>
+              </a:ext>
+            </a:extLst>
+          </p:cNvPr>
+          <p:cNvSpPr/>
+          <p:nvPr/>
+        </p:nvSpPr>
+        <p:spPr>
+          <a:xfrm>
+            <a:off x="4294689" y="4085208"/>
+            <a:ext cx="1097280" cy="146304"/>
+          </a:xfrm>
+          <a:prstGeom prst="rect">
+            <a:avLst/>
+          </a:prstGeom>
+          <a:noFill/>
+          <a:ln/>
+        </p:spPr>
+        <p:txBody>
+          <a:bodyPr wrap="square" lIns="127" tIns="127" rIns="127" bIns="127" rtlCol="0" anchor="ctr">
+            <a:noAutofit/>
+          </a:bodyPr>
+          <a:lstStyle/>
+          <a:p>
+            <a:pPr marL="0" indent="0" algn="ctr">
+              <a:buNone/>
+            </a:pPr>
+            <a:r>
+              <a:rPr lang="en-US" sz="1000" dirty="0">
+                <a:solidFill>
+                  <a:srgbClr val="0E2D63"/>
+                </a:solidFill>
+                <a:latin typeface="Arial" pitchFamily="34" charset="0"/>
+                <a:ea typeface="Arial" pitchFamily="34" charset="-122"/>
+                <a:cs typeface="Arial" pitchFamily="34" charset="-120"/>
+              </a:rPr>
+              <a:t>Updates the UI</a:t>
+            </a:r>
+            <a:endParaRPr lang="en-US" sz="1000" dirty="0"/>
+          </a:p>
+        </p:txBody>
+      </p:sp>
+      <p:sp>
+        <p:nvSpPr>
+          <p:cNvPr id="61" name="Shape 59">
+            <a:extLst>
+              <a:ext uri="{FF2B5EF4-FFF2-40B4-BE49-F238E27FC236}">
+                <a16:creationId xmlns:a16="http://schemas.microsoft.com/office/drawing/2014/main" id="{C3F0B8B6-A04D-C4E3-B848-60D514BC0B9F}"/>
+              </a:ext>
+            </a:extLst>
+          </p:cNvPr>
+          <p:cNvSpPr/>
+          <p:nvPr/>
+        </p:nvSpPr>
+        <p:spPr>
+          <a:xfrm>
+            <a:off x="6654475" y="3691186"/>
+            <a:ext cx="1" cy="1344168"/>
+          </a:xfrm>
+          <a:prstGeom prst="line">
+            <a:avLst/>
+          </a:prstGeom>
+          <a:noFill/>
+          <a:ln w="35560">
+            <a:solidFill>
+              <a:srgbClr val="12984B"/>
+            </a:solidFill>
+            <a:prstDash val="solid"/>
+          </a:ln>
+        </p:spPr>
+        <p:txBody>
+          <a:bodyPr/>
+          <a:lstStyle/>
+          <a:p>
+            <a:endParaRPr lang="en-US"/>
+          </a:p>
+        </p:txBody>
+      </p:sp>
+      <p:sp>
+        <p:nvSpPr>
+          <p:cNvPr id="62" name="Shape 60">
+            <a:extLst>
+              <a:ext uri="{FF2B5EF4-FFF2-40B4-BE49-F238E27FC236}">
+                <a16:creationId xmlns:a16="http://schemas.microsoft.com/office/drawing/2014/main" id="{99C624D6-A708-83B0-1E6E-B44E367B1909}"/>
+              </a:ext>
+            </a:extLst>
+          </p:cNvPr>
+          <p:cNvSpPr/>
+          <p:nvPr/>
+        </p:nvSpPr>
+        <p:spPr>
+          <a:xfrm flipH="1" flipV="1">
+            <a:off x="4223951" y="5047486"/>
+            <a:ext cx="2451169" cy="1"/>
+          </a:xfrm>
+          <a:prstGeom prst="line">
+            <a:avLst/>
+          </a:prstGeom>
+          <a:noFill/>
+          <a:ln w="35560">
+            <a:solidFill>
+              <a:srgbClr val="12984B"/>
+            </a:solidFill>
+            <a:prstDash val="solid"/>
+            <a:headEnd type="none"/>
+            <a:tailEnd type="triangle"/>
+          </a:ln>
+        </p:spPr>
+        <p:txBody>
+          <a:bodyPr/>
+          <a:lstStyle/>
+          <a:p>
+            <a:endParaRPr lang="en-US"/>
+          </a:p>
+        </p:txBody>
+      </p:sp>
+      <p:sp>
+        <p:nvSpPr>
+          <p:cNvPr id="63" name="Text 61">
+            <a:extLst>
+              <a:ext uri="{FF2B5EF4-FFF2-40B4-BE49-F238E27FC236}">
+                <a16:creationId xmlns:a16="http://schemas.microsoft.com/office/drawing/2014/main" id="{EAB606A9-C147-DBE8-F581-50E2D488A569}"/>
+              </a:ext>
+            </a:extLst>
+          </p:cNvPr>
+          <p:cNvSpPr/>
+          <p:nvPr/>
+        </p:nvSpPr>
+        <p:spPr>
+          <a:xfrm>
+            <a:off x="4655560" y="4799421"/>
+            <a:ext cx="1737360" cy="201168"/>
+          </a:xfrm>
+          <a:prstGeom prst="rect">
+            <a:avLst/>
+          </a:prstGeom>
+          <a:noFill/>
+          <a:ln/>
+        </p:spPr>
+        <p:txBody>
+          <a:bodyPr wrap="square" lIns="127" tIns="127" rIns="127" bIns="127" rtlCol="0" anchor="ctr">
+            <a:normAutofit/>
+          </a:bodyPr>
+          <a:lstStyle/>
+          <a:p>
+            <a:pPr marL="0" indent="0" algn="ctr">
+              <a:buNone/>
+            </a:pPr>
+            <a:r>
+              <a:rPr lang="en-US" sz="1200" b="1" dirty="0">
+                <a:solidFill>
+                  <a:srgbClr val="12984B"/>
+                </a:solidFill>
+                <a:latin typeface="Arial" pitchFamily="34" charset="0"/>
+                <a:ea typeface="Arial" pitchFamily="34" charset="-122"/>
+                <a:cs typeface="Arial" pitchFamily="34" charset="-120"/>
+              </a:rPr>
+              <a:t>defines UI structure</a:t>
+            </a:r>
+            <a:endParaRPr lang="en-US" sz="1200" dirty="0"/>
+          </a:p>
+        </p:txBody>
+      </p:sp>
+      <p:sp>
+        <p:nvSpPr>
+          <p:cNvPr id="64" name="Text 62">
+            <a:extLst>
+              <a:ext uri="{FF2B5EF4-FFF2-40B4-BE49-F238E27FC236}">
+                <a16:creationId xmlns:a16="http://schemas.microsoft.com/office/drawing/2014/main" id="{F6418945-9B42-2BBF-9A91-564ADAA5C1B3}"/>
+              </a:ext>
+            </a:extLst>
+          </p:cNvPr>
+          <p:cNvSpPr/>
+          <p:nvPr/>
+        </p:nvSpPr>
+        <p:spPr>
+          <a:xfrm>
+            <a:off x="4574128" y="5092460"/>
+            <a:ext cx="1965960" cy="347472"/>
+          </a:xfrm>
+          <a:prstGeom prst="rect">
+            <a:avLst/>
+          </a:prstGeom>
+          <a:noFill/>
+          <a:ln/>
+        </p:spPr>
+        <p:txBody>
+          <a:bodyPr wrap="square" lIns="127" tIns="127" rIns="127" bIns="127" rtlCol="0" anchor="ctr">
+            <a:normAutofit/>
+          </a:bodyPr>
+          <a:lstStyle/>
+          <a:p>
+            <a:pPr marL="0" indent="0" algn="ctr">
+              <a:buNone/>
+            </a:pPr>
+            <a:r>
+              <a:rPr lang="en-US" sz="1000" dirty="0">
+                <a:solidFill>
+                  <a:srgbClr val="0E2D63"/>
+                </a:solidFill>
+                <a:latin typeface="Arial" pitchFamily="34" charset="0"/>
+                <a:ea typeface="Arial" pitchFamily="34" charset="-122"/>
+                <a:cs typeface="Arial" pitchFamily="34" charset="-120"/>
+              </a:rPr>
+              <a:t>FXML defines what the UI</a:t>
+            </a:r>
+            <a:endParaRPr lang="en-US" sz="1000" dirty="0"/>
+          </a:p>
+          <a:p>
+            <a:pPr marL="0" indent="0" algn="ctr">
+              <a:buNone/>
+            </a:pPr>
+            <a:r>
+              <a:rPr lang="en-US" sz="1000" dirty="0">
+                <a:solidFill>
+                  <a:srgbClr val="0E2D63"/>
+                </a:solidFill>
+                <a:latin typeface="Arial" pitchFamily="34" charset="0"/>
+                <a:ea typeface="Arial" pitchFamily="34" charset="-122"/>
+                <a:cs typeface="Arial" pitchFamily="34" charset="-120"/>
+              </a:rPr>
+              <a:t>looks like (layout and controls)</a:t>
+            </a:r>
+            <a:endParaRPr lang="en-US" sz="1000" dirty="0"/>
+          </a:p>
+        </p:txBody>
+      </p:sp>
+      <p:sp>
+        <p:nvSpPr>
+          <p:cNvPr id="65" name="Shape 63">
+            <a:extLst>
+              <a:ext uri="{FF2B5EF4-FFF2-40B4-BE49-F238E27FC236}">
+                <a16:creationId xmlns:a16="http://schemas.microsoft.com/office/drawing/2014/main" id="{5EDD88DA-CE7E-D9B2-190D-AACF32A6BC13}"/>
+              </a:ext>
+            </a:extLst>
+          </p:cNvPr>
+          <p:cNvSpPr/>
+          <p:nvPr/>
+        </p:nvSpPr>
+        <p:spPr>
+          <a:xfrm flipH="1" flipV="1">
+            <a:off x="7757216" y="3717063"/>
+            <a:ext cx="1" cy="1088136"/>
+          </a:xfrm>
+          <a:prstGeom prst="line">
+            <a:avLst/>
+          </a:prstGeom>
+          <a:noFill/>
+          <a:ln w="33020">
+            <a:solidFill>
+              <a:srgbClr val="E61E73"/>
+            </a:solidFill>
+            <a:prstDash val="solid"/>
+            <a:headEnd type="none"/>
+            <a:tailEnd type="triangle"/>
+          </a:ln>
+        </p:spPr>
+        <p:txBody>
+          <a:bodyPr/>
+          <a:lstStyle/>
+          <a:p>
+            <a:endParaRPr lang="en-US"/>
+          </a:p>
+        </p:txBody>
+      </p:sp>
+      <p:sp>
+        <p:nvSpPr>
+          <p:cNvPr id="66" name="Text 64">
+            <a:extLst>
+              <a:ext uri="{FF2B5EF4-FFF2-40B4-BE49-F238E27FC236}">
+                <a16:creationId xmlns:a16="http://schemas.microsoft.com/office/drawing/2014/main" id="{EBAAA20D-FC62-9C20-EEBC-EED274042813}"/>
+              </a:ext>
+            </a:extLst>
+          </p:cNvPr>
+          <p:cNvSpPr/>
+          <p:nvPr/>
+        </p:nvSpPr>
+        <p:spPr>
+          <a:xfrm>
+            <a:off x="7863953" y="3890799"/>
+            <a:ext cx="1086347" cy="347472"/>
+          </a:xfrm>
+          <a:prstGeom prst="rect">
+            <a:avLst/>
+          </a:prstGeom>
+          <a:noFill/>
+          <a:ln/>
+        </p:spPr>
+        <p:txBody>
+          <a:bodyPr wrap="square" lIns="127" tIns="127" rIns="127" bIns="127" rtlCol="0" anchor="ctr">
+            <a:noAutofit/>
+          </a:bodyPr>
+          <a:lstStyle/>
+          <a:p>
+            <a:pPr marL="0" indent="0" algn="ctr">
+              <a:buNone/>
+            </a:pPr>
+            <a:r>
+              <a:rPr lang="en-US" sz="1200" b="1" dirty="0">
+                <a:solidFill>
+                  <a:srgbClr val="E61E73"/>
+                </a:solidFill>
+                <a:latin typeface="Arial" pitchFamily="34" charset="0"/>
+                <a:ea typeface="Arial" pitchFamily="34" charset="-122"/>
+                <a:cs typeface="Arial" pitchFamily="34" charset="-120"/>
+              </a:rPr>
+              <a:t>referenced in</a:t>
+            </a:r>
+            <a:endParaRPr lang="en-US" sz="1200" dirty="0"/>
+          </a:p>
+          <a:p>
+            <a:pPr marL="0" indent="0" algn="ctr">
+              <a:buNone/>
+            </a:pPr>
+            <a:r>
+              <a:rPr lang="en-US" sz="1200" b="1" dirty="0">
+                <a:solidFill>
+                  <a:srgbClr val="E61E73"/>
+                </a:solidFill>
+                <a:latin typeface="Arial" pitchFamily="34" charset="0"/>
+                <a:ea typeface="Arial" pitchFamily="34" charset="-122"/>
+                <a:cs typeface="Arial" pitchFamily="34" charset="-120"/>
+              </a:rPr>
+              <a:t>&lt;stylesheets&gt;</a:t>
+            </a:r>
+            <a:endParaRPr lang="en-US" sz="1200" dirty="0"/>
+          </a:p>
+        </p:txBody>
+      </p:sp>
+      <p:sp>
+        <p:nvSpPr>
+          <p:cNvPr id="67" name="Text 65">
+            <a:extLst>
+              <a:ext uri="{FF2B5EF4-FFF2-40B4-BE49-F238E27FC236}">
+                <a16:creationId xmlns:a16="http://schemas.microsoft.com/office/drawing/2014/main" id="{D009F1E7-F006-4A90-8549-330FBE52B629}"/>
+              </a:ext>
+            </a:extLst>
+          </p:cNvPr>
+          <p:cNvSpPr/>
+          <p:nvPr/>
+        </p:nvSpPr>
+        <p:spPr>
+          <a:xfrm>
+            <a:off x="7863953" y="4267629"/>
+            <a:ext cx="1039365" cy="438912"/>
+          </a:xfrm>
+          <a:prstGeom prst="rect">
+            <a:avLst/>
+          </a:prstGeom>
+          <a:noFill/>
+          <a:ln/>
+        </p:spPr>
+        <p:txBody>
+          <a:bodyPr wrap="square" lIns="127" tIns="127" rIns="127" bIns="127" rtlCol="0" anchor="ctr">
+            <a:noAutofit/>
+          </a:bodyPr>
+          <a:lstStyle/>
+          <a:p>
+            <a:pPr marL="0" indent="0" algn="ctr">
+              <a:buNone/>
+            </a:pPr>
+            <a:r>
+              <a:rPr lang="en-US" sz="1000" dirty="0">
+                <a:solidFill>
+                  <a:srgbClr val="0E2D63"/>
+                </a:solidFill>
+                <a:latin typeface="Arial" pitchFamily="34" charset="0"/>
+                <a:ea typeface="Arial" pitchFamily="34" charset="-122"/>
+                <a:cs typeface="Arial" pitchFamily="34" charset="-120"/>
+              </a:rPr>
+              <a:t>CSS controls the</a:t>
+            </a:r>
+            <a:endParaRPr lang="en-US" sz="1000" dirty="0"/>
+          </a:p>
+          <a:p>
+            <a:pPr marL="0" indent="0" algn="ctr">
+              <a:buNone/>
+            </a:pPr>
+            <a:r>
+              <a:rPr lang="en-US" sz="1000" dirty="0">
+                <a:solidFill>
+                  <a:srgbClr val="0E2D63"/>
+                </a:solidFill>
+                <a:latin typeface="Arial" pitchFamily="34" charset="0"/>
+                <a:ea typeface="Arial" pitchFamily="34" charset="-122"/>
+                <a:cs typeface="Arial" pitchFamily="34" charset="-120"/>
+              </a:rPr>
+              <a:t>appearance</a:t>
+            </a:r>
+            <a:endParaRPr lang="en-US" sz="1000" dirty="0"/>
+          </a:p>
+          <a:p>
+            <a:pPr marL="0" indent="0" algn="ctr">
+              <a:buNone/>
+            </a:pPr>
+            <a:r>
+              <a:rPr lang="en-US" sz="1000" dirty="0">
+                <a:solidFill>
+                  <a:srgbClr val="0E2D63"/>
+                </a:solidFill>
+                <a:latin typeface="Arial" pitchFamily="34" charset="0"/>
+                <a:ea typeface="Arial" pitchFamily="34" charset="-122"/>
+                <a:cs typeface="Arial" pitchFamily="34" charset="-120"/>
+              </a:rPr>
+              <a:t>(colors, fonts)</a:t>
+            </a:r>
+            <a:endParaRPr lang="en-US" sz="1000" dirty="0"/>
+          </a:p>
+        </p:txBody>
+      </p:sp>
+    </p:spTree>
+    <p:extLst>
+      <p:ext uri="{BB962C8B-B14F-4D97-AF65-F5344CB8AC3E}">
+        <p14:creationId xmlns:p14="http://schemas.microsoft.com/office/powerpoint/2010/main" val="1485039361"/>
+      </p:ext>
+    </p:extLst>
+  </p:cSld>
+  <p:clrMapOvr>
+    <a:masterClrMapping/>
+  </p:clrMapOvr>
+</p:sld>
+</file>
+
 <file path=ppt/slides/slide3.xml><?xml version="1.0" encoding="utf-8"?>
 <p:sld xmlns:a="http://schemas.openxmlformats.org/drawingml/2006/main" xmlns:r="http://schemas.openxmlformats.org/officeDocument/2006/relationships" xmlns:p="http://schemas.openxmlformats.org/presentationml/2006/main">
   <p:cSld>

</xml_diff>